<commit_message>
docs: record default workspace provider evaluation
</commit_message>
<xml_diff>
--- a/output/submission/御网智元-初审答辩.pptx
+++ b/output/submission/御网智元-初审答辩.pptx
@@ -143,7 +143,7 @@
           <p:cNvPr id="2" name="标题 1">
             <a:extLst>
               <a:ext uri="{FF2B5EF4-FFF2-40B4-BE49-F238E27FC236}">
-                <a16:creationId xmlns:a16="http://schemas.microsoft.com/office/drawing/2014/main" id="{62C858DD-D9A8-4223-249A-338E692F73A0}"/>
+                <a16:creationId xmlns:a16="http://schemas.microsoft.com/office/drawing/2014/main" id="{7D2491A0-9C09-5500-3410-6944559ACAC6}"/>
               </a:ext>
             </a:extLst>
           </p:cNvPr>
@@ -180,7 +180,7 @@
           <p:cNvPr id="3" name="副标题 2">
             <a:extLst>
               <a:ext uri="{FF2B5EF4-FFF2-40B4-BE49-F238E27FC236}">
-                <a16:creationId xmlns:a16="http://schemas.microsoft.com/office/drawing/2014/main" id="{52824E59-3F0B-DD80-9CB8-E206DB0AEEB1}"/>
+                <a16:creationId xmlns:a16="http://schemas.microsoft.com/office/drawing/2014/main" id="{ACE5D4E1-6D3B-36D4-CC93-B652720020FA}"/>
               </a:ext>
             </a:extLst>
           </p:cNvPr>
@@ -250,7 +250,7 @@
           <p:cNvPr id="4" name="日期占位符 3">
             <a:extLst>
               <a:ext uri="{FF2B5EF4-FFF2-40B4-BE49-F238E27FC236}">
-                <a16:creationId xmlns:a16="http://schemas.microsoft.com/office/drawing/2014/main" id="{DDA1B27C-C247-CDB1-4CB6-35C006DC101F}"/>
+                <a16:creationId xmlns:a16="http://schemas.microsoft.com/office/drawing/2014/main" id="{847B96F3-3EC6-1A8E-5548-DD6512D179D3}"/>
               </a:ext>
             </a:extLst>
           </p:cNvPr>
@@ -266,7 +266,7 @@
           <a:bodyPr/>
           <a:lstStyle/>
           <a:p>
-            <a:fld id="{D3686F46-09AC-4C45-9CBB-696853B6A77C}" type="datetimeFigureOut">
+            <a:fld id="{CED02E37-212D-45E5-B99C-39C388832D03}" type="datetimeFigureOut">
               <a:rPr lang="zh-CN" altLang="en-US" smtClean="0"/>
               <a:t>2026/8/28</a:t>
             </a:fld>
@@ -279,7 +279,7 @@
           <p:cNvPr id="5" name="页脚占位符 4">
             <a:extLst>
               <a:ext uri="{FF2B5EF4-FFF2-40B4-BE49-F238E27FC236}">
-                <a16:creationId xmlns:a16="http://schemas.microsoft.com/office/drawing/2014/main" id="{FCD07508-AD15-CD3C-C194-85C9CD3A0B8A}"/>
+                <a16:creationId xmlns:a16="http://schemas.microsoft.com/office/drawing/2014/main" id="{5C143C4C-5CBF-F3EE-1333-A1F6C5C6B505}"/>
               </a:ext>
             </a:extLst>
           </p:cNvPr>
@@ -304,7 +304,7 @@
           <p:cNvPr id="6" name="灯片编号占位符 5">
             <a:extLst>
               <a:ext uri="{FF2B5EF4-FFF2-40B4-BE49-F238E27FC236}">
-                <a16:creationId xmlns:a16="http://schemas.microsoft.com/office/drawing/2014/main" id="{12AC032B-89BF-4848-5260-C07A1581EE49}"/>
+                <a16:creationId xmlns:a16="http://schemas.microsoft.com/office/drawing/2014/main" id="{7C81286C-CC0C-49B7-7BEE-A0E980D9AD78}"/>
               </a:ext>
             </a:extLst>
           </p:cNvPr>
@@ -320,7 +320,7 @@
           <a:bodyPr/>
           <a:lstStyle/>
           <a:p>
-            <a:fld id="{B596C6F9-AC52-470D-9729-16F513593429}" type="slidenum">
+            <a:fld id="{50F8AA30-6A0A-4627-AFFB-93DB5BD0E750}" type="slidenum">
               <a:rPr lang="zh-CN" altLang="en-US" smtClean="0"/>
               <a:t>‹#›</a:t>
             </a:fld>
@@ -331,7 +331,7 @@
     </p:spTree>
     <p:extLst>
       <p:ext uri="{BB962C8B-B14F-4D97-AF65-F5344CB8AC3E}">
-        <p14:creationId xmlns:p14="http://schemas.microsoft.com/office/powerpoint/2010/main" val="892811731"/>
+        <p14:creationId xmlns:p14="http://schemas.microsoft.com/office/powerpoint/2010/main" val="2173889015"/>
       </p:ext>
     </p:extLst>
   </p:cSld>
@@ -363,7 +363,7 @@
           <p:cNvPr id="2" name="标题 1">
             <a:extLst>
               <a:ext uri="{FF2B5EF4-FFF2-40B4-BE49-F238E27FC236}">
-                <a16:creationId xmlns:a16="http://schemas.microsoft.com/office/drawing/2014/main" id="{97AF28FB-E3A1-7898-06E7-14386BA7B7D2}"/>
+                <a16:creationId xmlns:a16="http://schemas.microsoft.com/office/drawing/2014/main" id="{BB19CE30-FC2D-7047-6B02-158136A6F6B7}"/>
               </a:ext>
             </a:extLst>
           </p:cNvPr>
@@ -391,7 +391,7 @@
           <p:cNvPr id="3" name="竖排文字占位符 2">
             <a:extLst>
               <a:ext uri="{FF2B5EF4-FFF2-40B4-BE49-F238E27FC236}">
-                <a16:creationId xmlns:a16="http://schemas.microsoft.com/office/drawing/2014/main" id="{CBFC3F0C-BF23-1822-5479-63D77DC4224F}"/>
+                <a16:creationId xmlns:a16="http://schemas.microsoft.com/office/drawing/2014/main" id="{13FB6935-564A-3D1F-EE7F-F5010C3EBABC}"/>
               </a:ext>
             </a:extLst>
           </p:cNvPr>
@@ -448,7 +448,7 @@
           <p:cNvPr id="4" name="日期占位符 3">
             <a:extLst>
               <a:ext uri="{FF2B5EF4-FFF2-40B4-BE49-F238E27FC236}">
-                <a16:creationId xmlns:a16="http://schemas.microsoft.com/office/drawing/2014/main" id="{26AD3F95-8DAA-70C4-07D3-A143D17ED890}"/>
+                <a16:creationId xmlns:a16="http://schemas.microsoft.com/office/drawing/2014/main" id="{3869DCE3-2156-83F6-311A-7B4B30A25B2C}"/>
               </a:ext>
             </a:extLst>
           </p:cNvPr>
@@ -464,7 +464,7 @@
           <a:bodyPr/>
           <a:lstStyle/>
           <a:p>
-            <a:fld id="{D3686F46-09AC-4C45-9CBB-696853B6A77C}" type="datetimeFigureOut">
+            <a:fld id="{CED02E37-212D-45E5-B99C-39C388832D03}" type="datetimeFigureOut">
               <a:rPr lang="zh-CN" altLang="en-US" smtClean="0"/>
               <a:t>2026/8/28</a:t>
             </a:fld>
@@ -477,7 +477,7 @@
           <p:cNvPr id="5" name="页脚占位符 4">
             <a:extLst>
               <a:ext uri="{FF2B5EF4-FFF2-40B4-BE49-F238E27FC236}">
-                <a16:creationId xmlns:a16="http://schemas.microsoft.com/office/drawing/2014/main" id="{336B89E3-1ACE-3D04-9560-3DC36137243F}"/>
+                <a16:creationId xmlns:a16="http://schemas.microsoft.com/office/drawing/2014/main" id="{0DB00D96-30B3-305E-BBFA-0A027CD70EAB}"/>
               </a:ext>
             </a:extLst>
           </p:cNvPr>
@@ -502,7 +502,7 @@
           <p:cNvPr id="6" name="灯片编号占位符 5">
             <a:extLst>
               <a:ext uri="{FF2B5EF4-FFF2-40B4-BE49-F238E27FC236}">
-                <a16:creationId xmlns:a16="http://schemas.microsoft.com/office/drawing/2014/main" id="{A3A9CF63-0EFD-994B-2CCE-24371CE8450C}"/>
+                <a16:creationId xmlns:a16="http://schemas.microsoft.com/office/drawing/2014/main" id="{F39A2D97-6685-5185-55B8-A8A3B05BB575}"/>
               </a:ext>
             </a:extLst>
           </p:cNvPr>
@@ -518,7 +518,7 @@
           <a:bodyPr/>
           <a:lstStyle/>
           <a:p>
-            <a:fld id="{B596C6F9-AC52-470D-9729-16F513593429}" type="slidenum">
+            <a:fld id="{50F8AA30-6A0A-4627-AFFB-93DB5BD0E750}" type="slidenum">
               <a:rPr lang="zh-CN" altLang="en-US" smtClean="0"/>
               <a:t>‹#›</a:t>
             </a:fld>
@@ -529,7 +529,7 @@
     </p:spTree>
     <p:extLst>
       <p:ext uri="{BB962C8B-B14F-4D97-AF65-F5344CB8AC3E}">
-        <p14:creationId xmlns:p14="http://schemas.microsoft.com/office/powerpoint/2010/main" val="3209374465"/>
+        <p14:creationId xmlns:p14="http://schemas.microsoft.com/office/powerpoint/2010/main" val="539794627"/>
       </p:ext>
     </p:extLst>
   </p:cSld>
@@ -561,7 +561,7 @@
           <p:cNvPr id="2" name="竖排标题 1">
             <a:extLst>
               <a:ext uri="{FF2B5EF4-FFF2-40B4-BE49-F238E27FC236}">
-                <a16:creationId xmlns:a16="http://schemas.microsoft.com/office/drawing/2014/main" id="{02ADA1C7-D1C8-7BE5-BFE9-91092924DD98}"/>
+                <a16:creationId xmlns:a16="http://schemas.microsoft.com/office/drawing/2014/main" id="{B0C0A99C-3E8A-438E-26CE-48321B9C1C06}"/>
               </a:ext>
             </a:extLst>
           </p:cNvPr>
@@ -594,7 +594,7 @@
           <p:cNvPr id="3" name="竖排文字占位符 2">
             <a:extLst>
               <a:ext uri="{FF2B5EF4-FFF2-40B4-BE49-F238E27FC236}">
-                <a16:creationId xmlns:a16="http://schemas.microsoft.com/office/drawing/2014/main" id="{CDE71A1A-FFEC-C9FC-6EAA-168BF4E8D983}"/>
+                <a16:creationId xmlns:a16="http://schemas.microsoft.com/office/drawing/2014/main" id="{6618E84B-2DAE-515F-67E4-19CE0977161B}"/>
               </a:ext>
             </a:extLst>
           </p:cNvPr>
@@ -656,7 +656,7 @@
           <p:cNvPr id="4" name="日期占位符 3">
             <a:extLst>
               <a:ext uri="{FF2B5EF4-FFF2-40B4-BE49-F238E27FC236}">
-                <a16:creationId xmlns:a16="http://schemas.microsoft.com/office/drawing/2014/main" id="{AD894C3B-D6CB-7895-7D86-B6BFEE6CE6D5}"/>
+                <a16:creationId xmlns:a16="http://schemas.microsoft.com/office/drawing/2014/main" id="{DE826D2B-3E8E-1B9B-533A-4F8068803D55}"/>
               </a:ext>
             </a:extLst>
           </p:cNvPr>
@@ -672,7 +672,7 @@
           <a:bodyPr/>
           <a:lstStyle/>
           <a:p>
-            <a:fld id="{D3686F46-09AC-4C45-9CBB-696853B6A77C}" type="datetimeFigureOut">
+            <a:fld id="{CED02E37-212D-45E5-B99C-39C388832D03}" type="datetimeFigureOut">
               <a:rPr lang="zh-CN" altLang="en-US" smtClean="0"/>
               <a:t>2026/8/28</a:t>
             </a:fld>
@@ -685,7 +685,7 @@
           <p:cNvPr id="5" name="页脚占位符 4">
             <a:extLst>
               <a:ext uri="{FF2B5EF4-FFF2-40B4-BE49-F238E27FC236}">
-                <a16:creationId xmlns:a16="http://schemas.microsoft.com/office/drawing/2014/main" id="{833D8EA8-A51B-DDD4-0CAE-D933B5F15EF5}"/>
+                <a16:creationId xmlns:a16="http://schemas.microsoft.com/office/drawing/2014/main" id="{6549F495-40AB-D6E2-B11C-2A6F2AA0D133}"/>
               </a:ext>
             </a:extLst>
           </p:cNvPr>
@@ -710,7 +710,7 @@
           <p:cNvPr id="6" name="灯片编号占位符 5">
             <a:extLst>
               <a:ext uri="{FF2B5EF4-FFF2-40B4-BE49-F238E27FC236}">
-                <a16:creationId xmlns:a16="http://schemas.microsoft.com/office/drawing/2014/main" id="{9F436018-74FA-6C40-F126-E3D756927578}"/>
+                <a16:creationId xmlns:a16="http://schemas.microsoft.com/office/drawing/2014/main" id="{6D1E4A68-87EB-4642-AC95-8E520C43CDE7}"/>
               </a:ext>
             </a:extLst>
           </p:cNvPr>
@@ -726,7 +726,7 @@
           <a:bodyPr/>
           <a:lstStyle/>
           <a:p>
-            <a:fld id="{B596C6F9-AC52-470D-9729-16F513593429}" type="slidenum">
+            <a:fld id="{50F8AA30-6A0A-4627-AFFB-93DB5BD0E750}" type="slidenum">
               <a:rPr lang="zh-CN" altLang="en-US" smtClean="0"/>
               <a:t>‹#›</a:t>
             </a:fld>
@@ -737,7 +737,7 @@
     </p:spTree>
     <p:extLst>
       <p:ext uri="{BB962C8B-B14F-4D97-AF65-F5344CB8AC3E}">
-        <p14:creationId xmlns:p14="http://schemas.microsoft.com/office/powerpoint/2010/main" val="4191353490"/>
+        <p14:creationId xmlns:p14="http://schemas.microsoft.com/office/powerpoint/2010/main" val="1234760432"/>
       </p:ext>
     </p:extLst>
   </p:cSld>
@@ -769,7 +769,7 @@
           <p:cNvPr id="2" name="标题 1">
             <a:extLst>
               <a:ext uri="{FF2B5EF4-FFF2-40B4-BE49-F238E27FC236}">
-                <a16:creationId xmlns:a16="http://schemas.microsoft.com/office/drawing/2014/main" id="{4BE1A745-9D9E-1675-E116-E90B159D9CCC}"/>
+                <a16:creationId xmlns:a16="http://schemas.microsoft.com/office/drawing/2014/main" id="{DBF4BE88-B181-8874-D700-CADA76899B78}"/>
               </a:ext>
             </a:extLst>
           </p:cNvPr>
@@ -797,7 +797,7 @@
           <p:cNvPr id="3" name="内容占位符 2">
             <a:extLst>
               <a:ext uri="{FF2B5EF4-FFF2-40B4-BE49-F238E27FC236}">
-                <a16:creationId xmlns:a16="http://schemas.microsoft.com/office/drawing/2014/main" id="{3C50C1AB-3C6D-7241-5CF0-FC1F8A7DA94E}"/>
+                <a16:creationId xmlns:a16="http://schemas.microsoft.com/office/drawing/2014/main" id="{6E9D0364-2E25-9F87-585A-615549D4E244}"/>
               </a:ext>
             </a:extLst>
           </p:cNvPr>
@@ -854,7 +854,7 @@
           <p:cNvPr id="4" name="日期占位符 3">
             <a:extLst>
               <a:ext uri="{FF2B5EF4-FFF2-40B4-BE49-F238E27FC236}">
-                <a16:creationId xmlns:a16="http://schemas.microsoft.com/office/drawing/2014/main" id="{90F0A0C6-9054-6C16-64FB-654F6477732F}"/>
+                <a16:creationId xmlns:a16="http://schemas.microsoft.com/office/drawing/2014/main" id="{B124098C-290C-0C6C-10A3-27D5A4B7E049}"/>
               </a:ext>
             </a:extLst>
           </p:cNvPr>
@@ -870,7 +870,7 @@
           <a:bodyPr/>
           <a:lstStyle/>
           <a:p>
-            <a:fld id="{D3686F46-09AC-4C45-9CBB-696853B6A77C}" type="datetimeFigureOut">
+            <a:fld id="{CED02E37-212D-45E5-B99C-39C388832D03}" type="datetimeFigureOut">
               <a:rPr lang="zh-CN" altLang="en-US" smtClean="0"/>
               <a:t>2026/8/28</a:t>
             </a:fld>
@@ -883,7 +883,7 @@
           <p:cNvPr id="5" name="页脚占位符 4">
             <a:extLst>
               <a:ext uri="{FF2B5EF4-FFF2-40B4-BE49-F238E27FC236}">
-                <a16:creationId xmlns:a16="http://schemas.microsoft.com/office/drawing/2014/main" id="{F43661E4-F51F-4FA5-0930-2110A3745DDD}"/>
+                <a16:creationId xmlns:a16="http://schemas.microsoft.com/office/drawing/2014/main" id="{502F7843-2B91-CB73-A523-D63128E2B6AD}"/>
               </a:ext>
             </a:extLst>
           </p:cNvPr>
@@ -908,7 +908,7 @@
           <p:cNvPr id="6" name="灯片编号占位符 5">
             <a:extLst>
               <a:ext uri="{FF2B5EF4-FFF2-40B4-BE49-F238E27FC236}">
-                <a16:creationId xmlns:a16="http://schemas.microsoft.com/office/drawing/2014/main" id="{526CD18D-A599-E780-3924-5202E84FE723}"/>
+                <a16:creationId xmlns:a16="http://schemas.microsoft.com/office/drawing/2014/main" id="{F15B34E8-1079-9A8B-0306-E3652FFE9AFE}"/>
               </a:ext>
             </a:extLst>
           </p:cNvPr>
@@ -924,7 +924,7 @@
           <a:bodyPr/>
           <a:lstStyle/>
           <a:p>
-            <a:fld id="{B596C6F9-AC52-470D-9729-16F513593429}" type="slidenum">
+            <a:fld id="{50F8AA30-6A0A-4627-AFFB-93DB5BD0E750}" type="slidenum">
               <a:rPr lang="zh-CN" altLang="en-US" smtClean="0"/>
               <a:t>‹#›</a:t>
             </a:fld>
@@ -935,7 +935,7 @@
     </p:spTree>
     <p:extLst>
       <p:ext uri="{BB962C8B-B14F-4D97-AF65-F5344CB8AC3E}">
-        <p14:creationId xmlns:p14="http://schemas.microsoft.com/office/powerpoint/2010/main" val="2217168601"/>
+        <p14:creationId xmlns:p14="http://schemas.microsoft.com/office/powerpoint/2010/main" val="4035270942"/>
       </p:ext>
     </p:extLst>
   </p:cSld>
@@ -967,7 +967,7 @@
           <p:cNvPr id="2" name="标题 1">
             <a:extLst>
               <a:ext uri="{FF2B5EF4-FFF2-40B4-BE49-F238E27FC236}">
-                <a16:creationId xmlns:a16="http://schemas.microsoft.com/office/drawing/2014/main" id="{FBB4CE91-42F3-C98A-4CF9-063AE626B757}"/>
+                <a16:creationId xmlns:a16="http://schemas.microsoft.com/office/drawing/2014/main" id="{13E433E7-0E5E-1255-CF2E-DC2E31567587}"/>
               </a:ext>
             </a:extLst>
           </p:cNvPr>
@@ -1004,7 +1004,7 @@
           <p:cNvPr id="3" name="文本占位符 2">
             <a:extLst>
               <a:ext uri="{FF2B5EF4-FFF2-40B4-BE49-F238E27FC236}">
-                <a16:creationId xmlns:a16="http://schemas.microsoft.com/office/drawing/2014/main" id="{F0BA91A5-8681-E1B6-F5BF-EB1D79214E03}"/>
+                <a16:creationId xmlns:a16="http://schemas.microsoft.com/office/drawing/2014/main" id="{372C82F1-8F92-61ED-B890-B48F698BCCB2}"/>
               </a:ext>
             </a:extLst>
           </p:cNvPr>
@@ -1129,7 +1129,7 @@
           <p:cNvPr id="4" name="日期占位符 3">
             <a:extLst>
               <a:ext uri="{FF2B5EF4-FFF2-40B4-BE49-F238E27FC236}">
-                <a16:creationId xmlns:a16="http://schemas.microsoft.com/office/drawing/2014/main" id="{59C3DF94-22C7-29CD-999F-47FA820C0FE1}"/>
+                <a16:creationId xmlns:a16="http://schemas.microsoft.com/office/drawing/2014/main" id="{29C1A046-34E8-5E03-8473-E481136F59C0}"/>
               </a:ext>
             </a:extLst>
           </p:cNvPr>
@@ -1145,7 +1145,7 @@
           <a:bodyPr/>
           <a:lstStyle/>
           <a:p>
-            <a:fld id="{D3686F46-09AC-4C45-9CBB-696853B6A77C}" type="datetimeFigureOut">
+            <a:fld id="{CED02E37-212D-45E5-B99C-39C388832D03}" type="datetimeFigureOut">
               <a:rPr lang="zh-CN" altLang="en-US" smtClean="0"/>
               <a:t>2026/8/28</a:t>
             </a:fld>
@@ -1158,7 +1158,7 @@
           <p:cNvPr id="5" name="页脚占位符 4">
             <a:extLst>
               <a:ext uri="{FF2B5EF4-FFF2-40B4-BE49-F238E27FC236}">
-                <a16:creationId xmlns:a16="http://schemas.microsoft.com/office/drawing/2014/main" id="{2C5464AC-0B47-49D7-0327-65519A4AE043}"/>
+                <a16:creationId xmlns:a16="http://schemas.microsoft.com/office/drawing/2014/main" id="{3CF03968-9A71-499D-53EE-2FA8854CDB02}"/>
               </a:ext>
             </a:extLst>
           </p:cNvPr>
@@ -1183,7 +1183,7 @@
           <p:cNvPr id="6" name="灯片编号占位符 5">
             <a:extLst>
               <a:ext uri="{FF2B5EF4-FFF2-40B4-BE49-F238E27FC236}">
-                <a16:creationId xmlns:a16="http://schemas.microsoft.com/office/drawing/2014/main" id="{361186CD-B894-413E-309B-32D0BA7FF76D}"/>
+                <a16:creationId xmlns:a16="http://schemas.microsoft.com/office/drawing/2014/main" id="{1154BD0E-62C4-A6DC-D768-A00177B083EA}"/>
               </a:ext>
             </a:extLst>
           </p:cNvPr>
@@ -1199,7 +1199,7 @@
           <a:bodyPr/>
           <a:lstStyle/>
           <a:p>
-            <a:fld id="{B596C6F9-AC52-470D-9729-16F513593429}" type="slidenum">
+            <a:fld id="{50F8AA30-6A0A-4627-AFFB-93DB5BD0E750}" type="slidenum">
               <a:rPr lang="zh-CN" altLang="en-US" smtClean="0"/>
               <a:t>‹#›</a:t>
             </a:fld>
@@ -1210,7 +1210,7 @@
     </p:spTree>
     <p:extLst>
       <p:ext uri="{BB962C8B-B14F-4D97-AF65-F5344CB8AC3E}">
-        <p14:creationId xmlns:p14="http://schemas.microsoft.com/office/powerpoint/2010/main" val="111916777"/>
+        <p14:creationId xmlns:p14="http://schemas.microsoft.com/office/powerpoint/2010/main" val="254990457"/>
       </p:ext>
     </p:extLst>
   </p:cSld>
@@ -1242,7 +1242,7 @@
           <p:cNvPr id="2" name="标题 1">
             <a:extLst>
               <a:ext uri="{FF2B5EF4-FFF2-40B4-BE49-F238E27FC236}">
-                <a16:creationId xmlns:a16="http://schemas.microsoft.com/office/drawing/2014/main" id="{94EFF2FA-9838-41C1-C2B8-0FE7DF78F34E}"/>
+                <a16:creationId xmlns:a16="http://schemas.microsoft.com/office/drawing/2014/main" id="{F418663F-9188-4D0E-F57E-27DE1045047D}"/>
               </a:ext>
             </a:extLst>
           </p:cNvPr>
@@ -1270,7 +1270,7 @@
           <p:cNvPr id="3" name="内容占位符 2">
             <a:extLst>
               <a:ext uri="{FF2B5EF4-FFF2-40B4-BE49-F238E27FC236}">
-                <a16:creationId xmlns:a16="http://schemas.microsoft.com/office/drawing/2014/main" id="{C26FBA76-ADD5-3D28-9230-7534DE75C198}"/>
+                <a16:creationId xmlns:a16="http://schemas.microsoft.com/office/drawing/2014/main" id="{7E5974FB-CFE3-9608-E23F-CFDFDA8E50AE}"/>
               </a:ext>
             </a:extLst>
           </p:cNvPr>
@@ -1332,7 +1332,7 @@
           <p:cNvPr id="4" name="内容占位符 3">
             <a:extLst>
               <a:ext uri="{FF2B5EF4-FFF2-40B4-BE49-F238E27FC236}">
-                <a16:creationId xmlns:a16="http://schemas.microsoft.com/office/drawing/2014/main" id="{B94E49EE-666A-4688-C458-2252125EC918}"/>
+                <a16:creationId xmlns:a16="http://schemas.microsoft.com/office/drawing/2014/main" id="{6A05DB98-94DF-3F8D-EBDB-2F6016B39A5A}"/>
               </a:ext>
             </a:extLst>
           </p:cNvPr>
@@ -1394,7 +1394,7 @@
           <p:cNvPr id="5" name="日期占位符 4">
             <a:extLst>
               <a:ext uri="{FF2B5EF4-FFF2-40B4-BE49-F238E27FC236}">
-                <a16:creationId xmlns:a16="http://schemas.microsoft.com/office/drawing/2014/main" id="{89A1D7D1-BE67-2744-86F5-E87C60B3A80B}"/>
+                <a16:creationId xmlns:a16="http://schemas.microsoft.com/office/drawing/2014/main" id="{0ED4FB4B-6FBC-4656-D6ED-105A53594E23}"/>
               </a:ext>
             </a:extLst>
           </p:cNvPr>
@@ -1410,7 +1410,7 @@
           <a:bodyPr/>
           <a:lstStyle/>
           <a:p>
-            <a:fld id="{D3686F46-09AC-4C45-9CBB-696853B6A77C}" type="datetimeFigureOut">
+            <a:fld id="{CED02E37-212D-45E5-B99C-39C388832D03}" type="datetimeFigureOut">
               <a:rPr lang="zh-CN" altLang="en-US" smtClean="0"/>
               <a:t>2026/8/28</a:t>
             </a:fld>
@@ -1423,7 +1423,7 @@
           <p:cNvPr id="6" name="页脚占位符 5">
             <a:extLst>
               <a:ext uri="{FF2B5EF4-FFF2-40B4-BE49-F238E27FC236}">
-                <a16:creationId xmlns:a16="http://schemas.microsoft.com/office/drawing/2014/main" id="{277A59F4-B7E2-12AE-F5AC-1D8C5968DD3E}"/>
+                <a16:creationId xmlns:a16="http://schemas.microsoft.com/office/drawing/2014/main" id="{41116CF8-46E2-731C-A8B5-3ED70D4C7998}"/>
               </a:ext>
             </a:extLst>
           </p:cNvPr>
@@ -1448,7 +1448,7 @@
           <p:cNvPr id="7" name="灯片编号占位符 6">
             <a:extLst>
               <a:ext uri="{FF2B5EF4-FFF2-40B4-BE49-F238E27FC236}">
-                <a16:creationId xmlns:a16="http://schemas.microsoft.com/office/drawing/2014/main" id="{B3116134-4CE4-DAFC-63A0-3F6BC4921105}"/>
+                <a16:creationId xmlns:a16="http://schemas.microsoft.com/office/drawing/2014/main" id="{C7347E81-E2F8-9622-1CCC-BC2F14DC1DFC}"/>
               </a:ext>
             </a:extLst>
           </p:cNvPr>
@@ -1464,7 +1464,7 @@
           <a:bodyPr/>
           <a:lstStyle/>
           <a:p>
-            <a:fld id="{B596C6F9-AC52-470D-9729-16F513593429}" type="slidenum">
+            <a:fld id="{50F8AA30-6A0A-4627-AFFB-93DB5BD0E750}" type="slidenum">
               <a:rPr lang="zh-CN" altLang="en-US" smtClean="0"/>
               <a:t>‹#›</a:t>
             </a:fld>
@@ -1475,7 +1475,7 @@
     </p:spTree>
     <p:extLst>
       <p:ext uri="{BB962C8B-B14F-4D97-AF65-F5344CB8AC3E}">
-        <p14:creationId xmlns:p14="http://schemas.microsoft.com/office/powerpoint/2010/main" val="3009417038"/>
+        <p14:creationId xmlns:p14="http://schemas.microsoft.com/office/powerpoint/2010/main" val="2715904990"/>
       </p:ext>
     </p:extLst>
   </p:cSld>
@@ -1507,7 +1507,7 @@
           <p:cNvPr id="2" name="标题 1">
             <a:extLst>
               <a:ext uri="{FF2B5EF4-FFF2-40B4-BE49-F238E27FC236}">
-                <a16:creationId xmlns:a16="http://schemas.microsoft.com/office/drawing/2014/main" id="{37531BEC-F739-5078-B8DF-C0CE8CAF8E76}"/>
+                <a16:creationId xmlns:a16="http://schemas.microsoft.com/office/drawing/2014/main" id="{F4D0F2C7-8167-3971-727B-EDAF566AEA21}"/>
               </a:ext>
             </a:extLst>
           </p:cNvPr>
@@ -1540,7 +1540,7 @@
           <p:cNvPr id="3" name="文本占位符 2">
             <a:extLst>
               <a:ext uri="{FF2B5EF4-FFF2-40B4-BE49-F238E27FC236}">
-                <a16:creationId xmlns:a16="http://schemas.microsoft.com/office/drawing/2014/main" id="{E6BD6932-8A67-CFD7-E09A-FD9FEA3E2DAF}"/>
+                <a16:creationId xmlns:a16="http://schemas.microsoft.com/office/drawing/2014/main" id="{E8ABB00B-3674-0A98-5176-AA6DD21D9F06}"/>
               </a:ext>
             </a:extLst>
           </p:cNvPr>
@@ -1611,7 +1611,7 @@
           <p:cNvPr id="4" name="内容占位符 3">
             <a:extLst>
               <a:ext uri="{FF2B5EF4-FFF2-40B4-BE49-F238E27FC236}">
-                <a16:creationId xmlns:a16="http://schemas.microsoft.com/office/drawing/2014/main" id="{140A256A-9C25-7A4B-483A-4DB76BC387B6}"/>
+                <a16:creationId xmlns:a16="http://schemas.microsoft.com/office/drawing/2014/main" id="{5BB35009-F500-B861-54E9-DF2E1285D9A2}"/>
               </a:ext>
             </a:extLst>
           </p:cNvPr>
@@ -1673,7 +1673,7 @@
           <p:cNvPr id="5" name="文本占位符 4">
             <a:extLst>
               <a:ext uri="{FF2B5EF4-FFF2-40B4-BE49-F238E27FC236}">
-                <a16:creationId xmlns:a16="http://schemas.microsoft.com/office/drawing/2014/main" id="{EC425A74-E11B-D874-0B2C-07B94516A0A3}"/>
+                <a16:creationId xmlns:a16="http://schemas.microsoft.com/office/drawing/2014/main" id="{AB88E78E-B608-8AB4-F626-A0ADB417E321}"/>
               </a:ext>
             </a:extLst>
           </p:cNvPr>
@@ -1744,7 +1744,7 @@
           <p:cNvPr id="6" name="内容占位符 5">
             <a:extLst>
               <a:ext uri="{FF2B5EF4-FFF2-40B4-BE49-F238E27FC236}">
-                <a16:creationId xmlns:a16="http://schemas.microsoft.com/office/drawing/2014/main" id="{A8DA517A-9ECF-C43E-1A30-2DCE18348A26}"/>
+                <a16:creationId xmlns:a16="http://schemas.microsoft.com/office/drawing/2014/main" id="{9C611805-BB3E-9CAD-5DB4-AB1F54CB707B}"/>
               </a:ext>
             </a:extLst>
           </p:cNvPr>
@@ -1806,7 +1806,7 @@
           <p:cNvPr id="7" name="日期占位符 6">
             <a:extLst>
               <a:ext uri="{FF2B5EF4-FFF2-40B4-BE49-F238E27FC236}">
-                <a16:creationId xmlns:a16="http://schemas.microsoft.com/office/drawing/2014/main" id="{BB0E22F4-ADD9-40D8-7CE7-AA51D3124BE9}"/>
+                <a16:creationId xmlns:a16="http://schemas.microsoft.com/office/drawing/2014/main" id="{70B64962-95FD-2DEC-AEC9-F5F8026836F5}"/>
               </a:ext>
             </a:extLst>
           </p:cNvPr>
@@ -1822,7 +1822,7 @@
           <a:bodyPr/>
           <a:lstStyle/>
           <a:p>
-            <a:fld id="{D3686F46-09AC-4C45-9CBB-696853B6A77C}" type="datetimeFigureOut">
+            <a:fld id="{CED02E37-212D-45E5-B99C-39C388832D03}" type="datetimeFigureOut">
               <a:rPr lang="zh-CN" altLang="en-US" smtClean="0"/>
               <a:t>2026/8/28</a:t>
             </a:fld>
@@ -1835,7 +1835,7 @@
           <p:cNvPr id="8" name="页脚占位符 7">
             <a:extLst>
               <a:ext uri="{FF2B5EF4-FFF2-40B4-BE49-F238E27FC236}">
-                <a16:creationId xmlns:a16="http://schemas.microsoft.com/office/drawing/2014/main" id="{C91170EB-8C9D-226E-C391-AC95D48A3719}"/>
+                <a16:creationId xmlns:a16="http://schemas.microsoft.com/office/drawing/2014/main" id="{9567277C-C44F-054D-1ACD-55204EEE08B5}"/>
               </a:ext>
             </a:extLst>
           </p:cNvPr>
@@ -1860,7 +1860,7 @@
           <p:cNvPr id="9" name="灯片编号占位符 8">
             <a:extLst>
               <a:ext uri="{FF2B5EF4-FFF2-40B4-BE49-F238E27FC236}">
-                <a16:creationId xmlns:a16="http://schemas.microsoft.com/office/drawing/2014/main" id="{9967C24D-C85A-B5A6-0756-0514218F6ADD}"/>
+                <a16:creationId xmlns:a16="http://schemas.microsoft.com/office/drawing/2014/main" id="{AC1EC5F6-B4FD-B208-E170-076D39CF3B62}"/>
               </a:ext>
             </a:extLst>
           </p:cNvPr>
@@ -1876,7 +1876,7 @@
           <a:bodyPr/>
           <a:lstStyle/>
           <a:p>
-            <a:fld id="{B596C6F9-AC52-470D-9729-16F513593429}" type="slidenum">
+            <a:fld id="{50F8AA30-6A0A-4627-AFFB-93DB5BD0E750}" type="slidenum">
               <a:rPr lang="zh-CN" altLang="en-US" smtClean="0"/>
               <a:t>‹#›</a:t>
             </a:fld>
@@ -1887,7 +1887,7 @@
     </p:spTree>
     <p:extLst>
       <p:ext uri="{BB962C8B-B14F-4D97-AF65-F5344CB8AC3E}">
-        <p14:creationId xmlns:p14="http://schemas.microsoft.com/office/powerpoint/2010/main" val="944683704"/>
+        <p14:creationId xmlns:p14="http://schemas.microsoft.com/office/powerpoint/2010/main" val="4071687240"/>
       </p:ext>
     </p:extLst>
   </p:cSld>
@@ -1919,7 +1919,7 @@
           <p:cNvPr id="2" name="标题 1">
             <a:extLst>
               <a:ext uri="{FF2B5EF4-FFF2-40B4-BE49-F238E27FC236}">
-                <a16:creationId xmlns:a16="http://schemas.microsoft.com/office/drawing/2014/main" id="{A6D828CB-36DB-08A2-BAEB-EEA923CD62A4}"/>
+                <a16:creationId xmlns:a16="http://schemas.microsoft.com/office/drawing/2014/main" id="{ACF744B8-3C12-00E3-F4DE-5BF67D7FE01A}"/>
               </a:ext>
             </a:extLst>
           </p:cNvPr>
@@ -1947,7 +1947,7 @@
           <p:cNvPr id="3" name="日期占位符 2">
             <a:extLst>
               <a:ext uri="{FF2B5EF4-FFF2-40B4-BE49-F238E27FC236}">
-                <a16:creationId xmlns:a16="http://schemas.microsoft.com/office/drawing/2014/main" id="{EF195317-6BDF-2C03-2B78-B801A22EC9FE}"/>
+                <a16:creationId xmlns:a16="http://schemas.microsoft.com/office/drawing/2014/main" id="{F859DFE7-DF17-8EA1-44A3-360289C7AD85}"/>
               </a:ext>
             </a:extLst>
           </p:cNvPr>
@@ -1963,7 +1963,7 @@
           <a:bodyPr/>
           <a:lstStyle/>
           <a:p>
-            <a:fld id="{D3686F46-09AC-4C45-9CBB-696853B6A77C}" type="datetimeFigureOut">
+            <a:fld id="{CED02E37-212D-45E5-B99C-39C388832D03}" type="datetimeFigureOut">
               <a:rPr lang="zh-CN" altLang="en-US" smtClean="0"/>
               <a:t>2026/8/28</a:t>
             </a:fld>
@@ -1976,7 +1976,7 @@
           <p:cNvPr id="4" name="页脚占位符 3">
             <a:extLst>
               <a:ext uri="{FF2B5EF4-FFF2-40B4-BE49-F238E27FC236}">
-                <a16:creationId xmlns:a16="http://schemas.microsoft.com/office/drawing/2014/main" id="{3B14CB18-8483-3E2E-610D-0DC5A367DC42}"/>
+                <a16:creationId xmlns:a16="http://schemas.microsoft.com/office/drawing/2014/main" id="{D3F9FEA1-E4C9-B7E1-7DC9-9EA9F2619111}"/>
               </a:ext>
             </a:extLst>
           </p:cNvPr>
@@ -2001,7 +2001,7 @@
           <p:cNvPr id="5" name="灯片编号占位符 4">
             <a:extLst>
               <a:ext uri="{FF2B5EF4-FFF2-40B4-BE49-F238E27FC236}">
-                <a16:creationId xmlns:a16="http://schemas.microsoft.com/office/drawing/2014/main" id="{53CB59B4-7DC7-9722-1BDB-1D294F83EDB4}"/>
+                <a16:creationId xmlns:a16="http://schemas.microsoft.com/office/drawing/2014/main" id="{8E7DFF66-1194-1157-F079-781FD4D4CA10}"/>
               </a:ext>
             </a:extLst>
           </p:cNvPr>
@@ -2017,7 +2017,7 @@
           <a:bodyPr/>
           <a:lstStyle/>
           <a:p>
-            <a:fld id="{B596C6F9-AC52-470D-9729-16F513593429}" type="slidenum">
+            <a:fld id="{50F8AA30-6A0A-4627-AFFB-93DB5BD0E750}" type="slidenum">
               <a:rPr lang="zh-CN" altLang="en-US" smtClean="0"/>
               <a:t>‹#›</a:t>
             </a:fld>
@@ -2028,7 +2028,7 @@
     </p:spTree>
     <p:extLst>
       <p:ext uri="{BB962C8B-B14F-4D97-AF65-F5344CB8AC3E}">
-        <p14:creationId xmlns:p14="http://schemas.microsoft.com/office/powerpoint/2010/main" val="4247241698"/>
+        <p14:creationId xmlns:p14="http://schemas.microsoft.com/office/powerpoint/2010/main" val="4078141346"/>
       </p:ext>
     </p:extLst>
   </p:cSld>
@@ -2060,7 +2060,7 @@
           <p:cNvPr id="2" name="日期占位符 1">
             <a:extLst>
               <a:ext uri="{FF2B5EF4-FFF2-40B4-BE49-F238E27FC236}">
-                <a16:creationId xmlns:a16="http://schemas.microsoft.com/office/drawing/2014/main" id="{CCAFF5E1-8194-623A-C9E8-5C3C1811BDEE}"/>
+                <a16:creationId xmlns:a16="http://schemas.microsoft.com/office/drawing/2014/main" id="{672295BE-0BD5-8AE0-C17A-DC5C514CDED8}"/>
               </a:ext>
             </a:extLst>
           </p:cNvPr>
@@ -2076,7 +2076,7 @@
           <a:bodyPr/>
           <a:lstStyle/>
           <a:p>
-            <a:fld id="{D3686F46-09AC-4C45-9CBB-696853B6A77C}" type="datetimeFigureOut">
+            <a:fld id="{CED02E37-212D-45E5-B99C-39C388832D03}" type="datetimeFigureOut">
               <a:rPr lang="zh-CN" altLang="en-US" smtClean="0"/>
               <a:t>2026/8/28</a:t>
             </a:fld>
@@ -2089,7 +2089,7 @@
           <p:cNvPr id="3" name="页脚占位符 2">
             <a:extLst>
               <a:ext uri="{FF2B5EF4-FFF2-40B4-BE49-F238E27FC236}">
-                <a16:creationId xmlns:a16="http://schemas.microsoft.com/office/drawing/2014/main" id="{7885BBAF-B4D3-5353-6B89-D0406D452146}"/>
+                <a16:creationId xmlns:a16="http://schemas.microsoft.com/office/drawing/2014/main" id="{A0DB9A47-8CF3-1200-4DB8-0C47F6C8B9A3}"/>
               </a:ext>
             </a:extLst>
           </p:cNvPr>
@@ -2114,7 +2114,7 @@
           <p:cNvPr id="4" name="灯片编号占位符 3">
             <a:extLst>
               <a:ext uri="{FF2B5EF4-FFF2-40B4-BE49-F238E27FC236}">
-                <a16:creationId xmlns:a16="http://schemas.microsoft.com/office/drawing/2014/main" id="{D0908850-CDD5-227C-EAE2-FBA7C97FDEDB}"/>
+                <a16:creationId xmlns:a16="http://schemas.microsoft.com/office/drawing/2014/main" id="{8A4A9164-6C56-6DF4-21AE-9FC09713655F}"/>
               </a:ext>
             </a:extLst>
           </p:cNvPr>
@@ -2130,7 +2130,7 @@
           <a:bodyPr/>
           <a:lstStyle/>
           <a:p>
-            <a:fld id="{B596C6F9-AC52-470D-9729-16F513593429}" type="slidenum">
+            <a:fld id="{50F8AA30-6A0A-4627-AFFB-93DB5BD0E750}" type="slidenum">
               <a:rPr lang="zh-CN" altLang="en-US" smtClean="0"/>
               <a:t>‹#›</a:t>
             </a:fld>
@@ -2141,7 +2141,7 @@
     </p:spTree>
     <p:extLst>
       <p:ext uri="{BB962C8B-B14F-4D97-AF65-F5344CB8AC3E}">
-        <p14:creationId xmlns:p14="http://schemas.microsoft.com/office/powerpoint/2010/main" val="2632267300"/>
+        <p14:creationId xmlns:p14="http://schemas.microsoft.com/office/powerpoint/2010/main" val="3754812125"/>
       </p:ext>
     </p:extLst>
   </p:cSld>
@@ -2173,7 +2173,7 @@
           <p:cNvPr id="2" name="标题 1">
             <a:extLst>
               <a:ext uri="{FF2B5EF4-FFF2-40B4-BE49-F238E27FC236}">
-                <a16:creationId xmlns:a16="http://schemas.microsoft.com/office/drawing/2014/main" id="{7844D96E-C64F-860D-028A-68661BA72A0D}"/>
+                <a16:creationId xmlns:a16="http://schemas.microsoft.com/office/drawing/2014/main" id="{6D525077-61FF-5818-5434-D57819C25CE8}"/>
               </a:ext>
             </a:extLst>
           </p:cNvPr>
@@ -2210,7 +2210,7 @@
           <p:cNvPr id="3" name="内容占位符 2">
             <a:extLst>
               <a:ext uri="{FF2B5EF4-FFF2-40B4-BE49-F238E27FC236}">
-                <a16:creationId xmlns:a16="http://schemas.microsoft.com/office/drawing/2014/main" id="{C38FA9F6-9804-6398-40E0-378ADA47608D}"/>
+                <a16:creationId xmlns:a16="http://schemas.microsoft.com/office/drawing/2014/main" id="{1B206FA6-648D-8A18-2168-BB7E22764C32}"/>
               </a:ext>
             </a:extLst>
           </p:cNvPr>
@@ -2300,7 +2300,7 @@
           <p:cNvPr id="4" name="文本占位符 3">
             <a:extLst>
               <a:ext uri="{FF2B5EF4-FFF2-40B4-BE49-F238E27FC236}">
-                <a16:creationId xmlns:a16="http://schemas.microsoft.com/office/drawing/2014/main" id="{396C3062-9A49-4943-9FBE-1F5E81745CA7}"/>
+                <a16:creationId xmlns:a16="http://schemas.microsoft.com/office/drawing/2014/main" id="{73F7520B-070F-D3C0-C367-252221F30EE5}"/>
               </a:ext>
             </a:extLst>
           </p:cNvPr>
@@ -2371,7 +2371,7 @@
           <p:cNvPr id="5" name="日期占位符 4">
             <a:extLst>
               <a:ext uri="{FF2B5EF4-FFF2-40B4-BE49-F238E27FC236}">
-                <a16:creationId xmlns:a16="http://schemas.microsoft.com/office/drawing/2014/main" id="{6532D6F0-31AC-EF29-2658-5BA4346C3753}"/>
+                <a16:creationId xmlns:a16="http://schemas.microsoft.com/office/drawing/2014/main" id="{9D43FB37-D8F2-2EA8-A4B2-275905BBED6A}"/>
               </a:ext>
             </a:extLst>
           </p:cNvPr>
@@ -2387,7 +2387,7 @@
           <a:bodyPr/>
           <a:lstStyle/>
           <a:p>
-            <a:fld id="{D3686F46-09AC-4C45-9CBB-696853B6A77C}" type="datetimeFigureOut">
+            <a:fld id="{CED02E37-212D-45E5-B99C-39C388832D03}" type="datetimeFigureOut">
               <a:rPr lang="zh-CN" altLang="en-US" smtClean="0"/>
               <a:t>2026/8/28</a:t>
             </a:fld>
@@ -2400,7 +2400,7 @@
           <p:cNvPr id="6" name="页脚占位符 5">
             <a:extLst>
               <a:ext uri="{FF2B5EF4-FFF2-40B4-BE49-F238E27FC236}">
-                <a16:creationId xmlns:a16="http://schemas.microsoft.com/office/drawing/2014/main" id="{F72E6600-8471-6EBD-B2E1-50BDE6A4371A}"/>
+                <a16:creationId xmlns:a16="http://schemas.microsoft.com/office/drawing/2014/main" id="{733B043B-788F-465A-10A4-1405390A8934}"/>
               </a:ext>
             </a:extLst>
           </p:cNvPr>
@@ -2425,7 +2425,7 @@
           <p:cNvPr id="7" name="灯片编号占位符 6">
             <a:extLst>
               <a:ext uri="{FF2B5EF4-FFF2-40B4-BE49-F238E27FC236}">
-                <a16:creationId xmlns:a16="http://schemas.microsoft.com/office/drawing/2014/main" id="{EC061B7B-6F66-2CDF-E0C5-F4EFDA368213}"/>
+                <a16:creationId xmlns:a16="http://schemas.microsoft.com/office/drawing/2014/main" id="{3733CAEF-F5F1-E11E-6EFE-0FD40B59BCD5}"/>
               </a:ext>
             </a:extLst>
           </p:cNvPr>
@@ -2441,7 +2441,7 @@
           <a:bodyPr/>
           <a:lstStyle/>
           <a:p>
-            <a:fld id="{B596C6F9-AC52-470D-9729-16F513593429}" type="slidenum">
+            <a:fld id="{50F8AA30-6A0A-4627-AFFB-93DB5BD0E750}" type="slidenum">
               <a:rPr lang="zh-CN" altLang="en-US" smtClean="0"/>
               <a:t>‹#›</a:t>
             </a:fld>
@@ -2452,7 +2452,7 @@
     </p:spTree>
     <p:extLst>
       <p:ext uri="{BB962C8B-B14F-4D97-AF65-F5344CB8AC3E}">
-        <p14:creationId xmlns:p14="http://schemas.microsoft.com/office/powerpoint/2010/main" val="2994535101"/>
+        <p14:creationId xmlns:p14="http://schemas.microsoft.com/office/powerpoint/2010/main" val="2242995610"/>
       </p:ext>
     </p:extLst>
   </p:cSld>
@@ -2484,7 +2484,7 @@
           <p:cNvPr id="2" name="标题 1">
             <a:extLst>
               <a:ext uri="{FF2B5EF4-FFF2-40B4-BE49-F238E27FC236}">
-                <a16:creationId xmlns:a16="http://schemas.microsoft.com/office/drawing/2014/main" id="{6645AA0D-1F10-20D5-EB3C-647406E3A796}"/>
+                <a16:creationId xmlns:a16="http://schemas.microsoft.com/office/drawing/2014/main" id="{5E3D460E-E1EC-379E-356E-8FEF8401FAC5}"/>
               </a:ext>
             </a:extLst>
           </p:cNvPr>
@@ -2521,7 +2521,7 @@
           <p:cNvPr id="3" name="图片占位符 2">
             <a:extLst>
               <a:ext uri="{FF2B5EF4-FFF2-40B4-BE49-F238E27FC236}">
-                <a16:creationId xmlns:a16="http://schemas.microsoft.com/office/drawing/2014/main" id="{B9F16F79-185D-3C9E-6FFF-D975C921D4D4}"/>
+                <a16:creationId xmlns:a16="http://schemas.microsoft.com/office/drawing/2014/main" id="{A4826A54-1694-5320-C7F2-17F32511D2FB}"/>
               </a:ext>
             </a:extLst>
           </p:cNvPr>
@@ -2588,7 +2588,7 @@
           <p:cNvPr id="4" name="文本占位符 3">
             <a:extLst>
               <a:ext uri="{FF2B5EF4-FFF2-40B4-BE49-F238E27FC236}">
-                <a16:creationId xmlns:a16="http://schemas.microsoft.com/office/drawing/2014/main" id="{F2F3491F-2A30-B4AF-625F-245992A2E226}"/>
+                <a16:creationId xmlns:a16="http://schemas.microsoft.com/office/drawing/2014/main" id="{5770C93B-4618-AE97-FC45-78A2D95194F9}"/>
               </a:ext>
             </a:extLst>
           </p:cNvPr>
@@ -2659,7 +2659,7 @@
           <p:cNvPr id="5" name="日期占位符 4">
             <a:extLst>
               <a:ext uri="{FF2B5EF4-FFF2-40B4-BE49-F238E27FC236}">
-                <a16:creationId xmlns:a16="http://schemas.microsoft.com/office/drawing/2014/main" id="{0C334181-6B1F-A71A-936D-B466C7AB719B}"/>
+                <a16:creationId xmlns:a16="http://schemas.microsoft.com/office/drawing/2014/main" id="{9508C197-608D-AB0A-22FA-9023F89E8748}"/>
               </a:ext>
             </a:extLst>
           </p:cNvPr>
@@ -2675,7 +2675,7 @@
           <a:bodyPr/>
           <a:lstStyle/>
           <a:p>
-            <a:fld id="{D3686F46-09AC-4C45-9CBB-696853B6A77C}" type="datetimeFigureOut">
+            <a:fld id="{CED02E37-212D-45E5-B99C-39C388832D03}" type="datetimeFigureOut">
               <a:rPr lang="zh-CN" altLang="en-US" smtClean="0"/>
               <a:t>2026/8/28</a:t>
             </a:fld>
@@ -2688,7 +2688,7 @@
           <p:cNvPr id="6" name="页脚占位符 5">
             <a:extLst>
               <a:ext uri="{FF2B5EF4-FFF2-40B4-BE49-F238E27FC236}">
-                <a16:creationId xmlns:a16="http://schemas.microsoft.com/office/drawing/2014/main" id="{6617CAE4-2261-EDDC-5F2D-38D9A0DA751A}"/>
+                <a16:creationId xmlns:a16="http://schemas.microsoft.com/office/drawing/2014/main" id="{2197F35F-5F18-B020-ECC5-EA35D7BD8587}"/>
               </a:ext>
             </a:extLst>
           </p:cNvPr>
@@ -2713,7 +2713,7 @@
           <p:cNvPr id="7" name="灯片编号占位符 6">
             <a:extLst>
               <a:ext uri="{FF2B5EF4-FFF2-40B4-BE49-F238E27FC236}">
-                <a16:creationId xmlns:a16="http://schemas.microsoft.com/office/drawing/2014/main" id="{08ED3FD4-FD37-7A92-EDBC-23B3D2F413D7}"/>
+                <a16:creationId xmlns:a16="http://schemas.microsoft.com/office/drawing/2014/main" id="{1E65F4F9-F44E-D743-CA2C-DBBA442D3A26}"/>
               </a:ext>
             </a:extLst>
           </p:cNvPr>
@@ -2729,7 +2729,7 @@
           <a:bodyPr/>
           <a:lstStyle/>
           <a:p>
-            <a:fld id="{B596C6F9-AC52-470D-9729-16F513593429}" type="slidenum">
+            <a:fld id="{50F8AA30-6A0A-4627-AFFB-93DB5BD0E750}" type="slidenum">
               <a:rPr lang="zh-CN" altLang="en-US" smtClean="0"/>
               <a:t>‹#›</a:t>
             </a:fld>
@@ -2740,7 +2740,7 @@
     </p:spTree>
     <p:extLst>
       <p:ext uri="{BB962C8B-B14F-4D97-AF65-F5344CB8AC3E}">
-        <p14:creationId xmlns:p14="http://schemas.microsoft.com/office/powerpoint/2010/main" val="645999301"/>
+        <p14:creationId xmlns:p14="http://schemas.microsoft.com/office/powerpoint/2010/main" val="1478760219"/>
       </p:ext>
     </p:extLst>
   </p:cSld>
@@ -2777,7 +2777,7 @@
           <p:cNvPr id="2" name="标题占位符 1">
             <a:extLst>
               <a:ext uri="{FF2B5EF4-FFF2-40B4-BE49-F238E27FC236}">
-                <a16:creationId xmlns:a16="http://schemas.microsoft.com/office/drawing/2014/main" id="{9D11B7AF-26DA-1392-FF73-B28C36D2F399}"/>
+                <a16:creationId xmlns:a16="http://schemas.microsoft.com/office/drawing/2014/main" id="{02DB1D7A-C054-54E9-6604-EDC34AF4B96A}"/>
               </a:ext>
             </a:extLst>
           </p:cNvPr>
@@ -2815,7 +2815,7 @@
           <p:cNvPr id="3" name="文本占位符 2">
             <a:extLst>
               <a:ext uri="{FF2B5EF4-FFF2-40B4-BE49-F238E27FC236}">
-                <a16:creationId xmlns:a16="http://schemas.microsoft.com/office/drawing/2014/main" id="{8D8E5D54-63F0-CC35-EBA5-ED320D00608A}"/>
+                <a16:creationId xmlns:a16="http://schemas.microsoft.com/office/drawing/2014/main" id="{5ABCA269-9177-57D8-7B85-FA9DBA9B0953}"/>
               </a:ext>
             </a:extLst>
           </p:cNvPr>
@@ -2882,7 +2882,7 @@
           <p:cNvPr id="4" name="日期占位符 3">
             <a:extLst>
               <a:ext uri="{FF2B5EF4-FFF2-40B4-BE49-F238E27FC236}">
-                <a16:creationId xmlns:a16="http://schemas.microsoft.com/office/drawing/2014/main" id="{83E5FF49-A755-DDB5-2C6A-8B8E749B82E4}"/>
+                <a16:creationId xmlns:a16="http://schemas.microsoft.com/office/drawing/2014/main" id="{3C3C5830-82ED-6399-6F9F-A256AA3048B4}"/>
               </a:ext>
             </a:extLst>
           </p:cNvPr>
@@ -2916,7 +2916,7 @@
             </a:lvl1pPr>
           </a:lstStyle>
           <a:p>
-            <a:fld id="{D3686F46-09AC-4C45-9CBB-696853B6A77C}" type="datetimeFigureOut">
+            <a:fld id="{CED02E37-212D-45E5-B99C-39C388832D03}" type="datetimeFigureOut">
               <a:rPr lang="zh-CN" altLang="en-US" smtClean="0"/>
               <a:t>2026/8/28</a:t>
             </a:fld>
@@ -2929,7 +2929,7 @@
           <p:cNvPr id="5" name="页脚占位符 4">
             <a:extLst>
               <a:ext uri="{FF2B5EF4-FFF2-40B4-BE49-F238E27FC236}">
-                <a16:creationId xmlns:a16="http://schemas.microsoft.com/office/drawing/2014/main" id="{D168E1FC-8D5F-69F6-2F7D-D33638CBBC26}"/>
+                <a16:creationId xmlns:a16="http://schemas.microsoft.com/office/drawing/2014/main" id="{8CC3082B-9591-1227-C976-5EA8C992B328}"/>
               </a:ext>
             </a:extLst>
           </p:cNvPr>
@@ -2972,7 +2972,7 @@
           <p:cNvPr id="6" name="灯片编号占位符 5">
             <a:extLst>
               <a:ext uri="{FF2B5EF4-FFF2-40B4-BE49-F238E27FC236}">
-                <a16:creationId xmlns:a16="http://schemas.microsoft.com/office/drawing/2014/main" id="{49E48D72-F381-FBC4-1F03-35F8DC40A09C}"/>
+                <a16:creationId xmlns:a16="http://schemas.microsoft.com/office/drawing/2014/main" id="{757A0BF8-C8E4-8526-1A38-B7AD9B836884}"/>
               </a:ext>
             </a:extLst>
           </p:cNvPr>
@@ -3006,7 +3006,7 @@
             </a:lvl1pPr>
           </a:lstStyle>
           <a:p>
-            <a:fld id="{B596C6F9-AC52-470D-9729-16F513593429}" type="slidenum">
+            <a:fld id="{50F8AA30-6A0A-4627-AFFB-93DB5BD0E750}" type="slidenum">
               <a:rPr lang="zh-CN" altLang="en-US" smtClean="0"/>
               <a:t>‹#›</a:t>
             </a:fld>
@@ -3017,7 +3017,7 @@
     </p:spTree>
     <p:extLst>
       <p:ext uri="{BB962C8B-B14F-4D97-AF65-F5344CB8AC3E}">
-        <p14:creationId xmlns:p14="http://schemas.microsoft.com/office/powerpoint/2010/main" val="3176102180"/>
+        <p14:creationId xmlns:p14="http://schemas.microsoft.com/office/powerpoint/2010/main" val="2527100922"/>
       </p:ext>
     </p:extLst>
   </p:cSld>
@@ -3340,7 +3340,7 @@
           <p:cNvPr id="2" name="矩形 1">
             <a:extLst>
               <a:ext uri="{FF2B5EF4-FFF2-40B4-BE49-F238E27FC236}">
-                <a16:creationId xmlns:a16="http://schemas.microsoft.com/office/drawing/2014/main" id="{4AF7DB65-E30A-5B03-9C61-426B8E88D9F7}"/>
+                <a16:creationId xmlns:a16="http://schemas.microsoft.com/office/drawing/2014/main" id="{0BE137B2-6060-64D1-B917-45B623AB5915}"/>
               </a:ext>
             </a:extLst>
           </p:cNvPr>
@@ -3408,7 +3408,7 @@
           <p:cNvPr id="3" name="文本框 2">
             <a:extLst>
               <a:ext uri="{FF2B5EF4-FFF2-40B4-BE49-F238E27FC236}">
-                <a16:creationId xmlns:a16="http://schemas.microsoft.com/office/drawing/2014/main" id="{332B5B00-BB45-3E9B-E3FA-6403C3AB27D7}"/>
+                <a16:creationId xmlns:a16="http://schemas.microsoft.com/office/drawing/2014/main" id="{DC624BEB-EE91-191E-CD1B-C7D49BE9DAA9}"/>
               </a:ext>
             </a:extLst>
           </p:cNvPr>
@@ -3449,7 +3449,7 @@
           <p:cNvPr id="4" name="文本框 3">
             <a:extLst>
               <a:ext uri="{FF2B5EF4-FFF2-40B4-BE49-F238E27FC236}">
-                <a16:creationId xmlns:a16="http://schemas.microsoft.com/office/drawing/2014/main" id="{02545109-99AF-320B-E1AD-E978A2DA3A28}"/>
+                <a16:creationId xmlns:a16="http://schemas.microsoft.com/office/drawing/2014/main" id="{1EB2D32C-CB4C-426D-8B83-CA53387D9186}"/>
               </a:ext>
             </a:extLst>
           </p:cNvPr>
@@ -3539,7 +3539,7 @@
           <p:cNvPr id="5" name="矩形 4">
             <a:extLst>
               <a:ext uri="{FF2B5EF4-FFF2-40B4-BE49-F238E27FC236}">
-                <a16:creationId xmlns:a16="http://schemas.microsoft.com/office/drawing/2014/main" id="{40C829C4-D2AB-8BD5-0EBF-9BC4F353DD2C}"/>
+                <a16:creationId xmlns:a16="http://schemas.microsoft.com/office/drawing/2014/main" id="{923EE635-C4A1-B51C-1CC3-C81A93698FBC}"/>
               </a:ext>
             </a:extLst>
           </p:cNvPr>
@@ -3607,7 +3607,7 @@
           <p:cNvPr id="6" name="文本框 5">
             <a:extLst>
               <a:ext uri="{FF2B5EF4-FFF2-40B4-BE49-F238E27FC236}">
-                <a16:creationId xmlns:a16="http://schemas.microsoft.com/office/drawing/2014/main" id="{E138B27E-F869-F46D-9123-7D1C32752981}"/>
+                <a16:creationId xmlns:a16="http://schemas.microsoft.com/office/drawing/2014/main" id="{32E90048-F1E7-3479-934C-E33F0034D3C0}"/>
               </a:ext>
             </a:extLst>
           </p:cNvPr>
@@ -3668,7 +3668,7 @@
           <p:cNvPr id="7" name="文本框 6">
             <a:extLst>
               <a:ext uri="{FF2B5EF4-FFF2-40B4-BE49-F238E27FC236}">
-                <a16:creationId xmlns:a16="http://schemas.microsoft.com/office/drawing/2014/main" id="{502EEE8D-AFA7-F20F-037C-A9BB580CAE9B}"/>
+                <a16:creationId xmlns:a16="http://schemas.microsoft.com/office/drawing/2014/main" id="{53E75FA0-9135-CDDD-99C7-9B86D340F187}"/>
               </a:ext>
             </a:extLst>
           </p:cNvPr>
@@ -3744,7 +3744,7 @@
     </p:spTree>
     <p:extLst>
       <p:ext uri="{BB962C8B-B14F-4D97-AF65-F5344CB8AC3E}">
-        <p14:creationId xmlns:p14="http://schemas.microsoft.com/office/powerpoint/2010/main" val="445064256"/>
+        <p14:creationId xmlns:p14="http://schemas.microsoft.com/office/powerpoint/2010/main" val="458070715"/>
       </p:ext>
     </p:extLst>
   </p:cSld>
@@ -3776,7 +3776,7 @@
           <p:cNvPr id="2" name="矩形 1">
             <a:extLst>
               <a:ext uri="{FF2B5EF4-FFF2-40B4-BE49-F238E27FC236}">
-                <a16:creationId xmlns:a16="http://schemas.microsoft.com/office/drawing/2014/main" id="{1430C6AB-3354-F036-CD33-FA88E07A4F73}"/>
+                <a16:creationId xmlns:a16="http://schemas.microsoft.com/office/drawing/2014/main" id="{06A4B266-F2AA-0835-A606-D16FF51D2A71}"/>
               </a:ext>
             </a:extLst>
           </p:cNvPr>
@@ -3844,7 +3844,7 @@
           <p:cNvPr id="3" name="文本框 2">
             <a:extLst>
               <a:ext uri="{FF2B5EF4-FFF2-40B4-BE49-F238E27FC236}">
-                <a16:creationId xmlns:a16="http://schemas.microsoft.com/office/drawing/2014/main" id="{A45AF361-B1C8-B55C-037D-73D5440F3C0E}"/>
+                <a16:creationId xmlns:a16="http://schemas.microsoft.com/office/drawing/2014/main" id="{FA057C20-63AB-3D54-AB83-D3A7E565EDE9}"/>
               </a:ext>
             </a:extLst>
           </p:cNvPr>
@@ -3885,7 +3885,7 @@
           <p:cNvPr id="4" name="文本框 3">
             <a:extLst>
               <a:ext uri="{FF2B5EF4-FFF2-40B4-BE49-F238E27FC236}">
-                <a16:creationId xmlns:a16="http://schemas.microsoft.com/office/drawing/2014/main" id="{F74407B0-BF7B-9B6D-0D89-BDDD71C50FFF}"/>
+                <a16:creationId xmlns:a16="http://schemas.microsoft.com/office/drawing/2014/main" id="{A70116D0-03E9-F914-B90F-B14E15F99EA3}"/>
               </a:ext>
             </a:extLst>
           </p:cNvPr>
@@ -3968,7 +3968,7 @@
           <p:cNvPr id="5" name="矩形 4">
             <a:extLst>
               <a:ext uri="{FF2B5EF4-FFF2-40B4-BE49-F238E27FC236}">
-                <a16:creationId xmlns:a16="http://schemas.microsoft.com/office/drawing/2014/main" id="{DA3758DF-CCA2-4E7B-B4E2-D8D1C5DBD869}"/>
+                <a16:creationId xmlns:a16="http://schemas.microsoft.com/office/drawing/2014/main" id="{7A593010-11F3-7812-D541-CCCBA089672F}"/>
               </a:ext>
             </a:extLst>
           </p:cNvPr>
@@ -4036,7 +4036,7 @@
           <p:cNvPr id="6" name="文本框 5">
             <a:extLst>
               <a:ext uri="{FF2B5EF4-FFF2-40B4-BE49-F238E27FC236}">
-                <a16:creationId xmlns:a16="http://schemas.microsoft.com/office/drawing/2014/main" id="{DF11BC10-EE04-73F1-8F57-CE48213CA789}"/>
+                <a16:creationId xmlns:a16="http://schemas.microsoft.com/office/drawing/2014/main" id="{68025B97-7B9F-6F1A-2F28-35F95D173AFC}"/>
               </a:ext>
             </a:extLst>
           </p:cNvPr>
@@ -4077,7 +4077,7 @@
           <p:cNvPr id="7" name="文本框 6">
             <a:extLst>
               <a:ext uri="{FF2B5EF4-FFF2-40B4-BE49-F238E27FC236}">
-                <a16:creationId xmlns:a16="http://schemas.microsoft.com/office/drawing/2014/main" id="{E649F73D-69E6-6DA9-2004-777623307E92}"/>
+                <a16:creationId xmlns:a16="http://schemas.microsoft.com/office/drawing/2014/main" id="{E0790B10-A302-2000-DC11-1114F01BCFD5}"/>
               </a:ext>
             </a:extLst>
           </p:cNvPr>
@@ -4153,7 +4153,7 @@
     </p:spTree>
     <p:extLst>
       <p:ext uri="{BB962C8B-B14F-4D97-AF65-F5344CB8AC3E}">
-        <p14:creationId xmlns:p14="http://schemas.microsoft.com/office/powerpoint/2010/main" val="1282772763"/>
+        <p14:creationId xmlns:p14="http://schemas.microsoft.com/office/powerpoint/2010/main" val="1122989559"/>
       </p:ext>
     </p:extLst>
   </p:cSld>
@@ -4185,7 +4185,7 @@
           <p:cNvPr id="2" name="矩形 1">
             <a:extLst>
               <a:ext uri="{FF2B5EF4-FFF2-40B4-BE49-F238E27FC236}">
-                <a16:creationId xmlns:a16="http://schemas.microsoft.com/office/drawing/2014/main" id="{A9B2BB89-04BF-6D2E-DC23-89AAB12F5CAC}"/>
+                <a16:creationId xmlns:a16="http://schemas.microsoft.com/office/drawing/2014/main" id="{478FBD63-E369-822E-1066-163BD9F2F952}"/>
               </a:ext>
             </a:extLst>
           </p:cNvPr>
@@ -4253,7 +4253,7 @@
           <p:cNvPr id="3" name="文本框 2">
             <a:extLst>
               <a:ext uri="{FF2B5EF4-FFF2-40B4-BE49-F238E27FC236}">
-                <a16:creationId xmlns:a16="http://schemas.microsoft.com/office/drawing/2014/main" id="{495072FB-1B08-7BEE-852C-A08E118605AC}"/>
+                <a16:creationId xmlns:a16="http://schemas.microsoft.com/office/drawing/2014/main" id="{B9B5884A-BF66-0876-86DC-09B86866EF84}"/>
               </a:ext>
             </a:extLst>
           </p:cNvPr>
@@ -4294,7 +4294,7 @@
           <p:cNvPr id="4" name="文本框 3">
             <a:extLst>
               <a:ext uri="{FF2B5EF4-FFF2-40B4-BE49-F238E27FC236}">
-                <a16:creationId xmlns:a16="http://schemas.microsoft.com/office/drawing/2014/main" id="{5D5BEAEC-A7E1-7349-F1C7-8415D30AFBE4}"/>
+                <a16:creationId xmlns:a16="http://schemas.microsoft.com/office/drawing/2014/main" id="{850734DF-EE94-BD5D-2450-629B3822E356}"/>
               </a:ext>
             </a:extLst>
           </p:cNvPr>
@@ -4397,7 +4397,7 @@
           <p:cNvPr id="6" name="图片 5">
             <a:extLst>
               <a:ext uri="{FF2B5EF4-FFF2-40B4-BE49-F238E27FC236}">
-                <a16:creationId xmlns:a16="http://schemas.microsoft.com/office/drawing/2014/main" id="{05F1D475-F076-9FB7-3923-66F130218C51}"/>
+                <a16:creationId xmlns:a16="http://schemas.microsoft.com/office/drawing/2014/main" id="{236D13B5-894F-D5E3-D386-7CEE5D07093C}"/>
               </a:ext>
             </a:extLst>
           </p:cNvPr>
@@ -4433,7 +4433,7 @@
           <p:cNvPr id="7" name="矩形 6">
             <a:extLst>
               <a:ext uri="{FF2B5EF4-FFF2-40B4-BE49-F238E27FC236}">
-                <a16:creationId xmlns:a16="http://schemas.microsoft.com/office/drawing/2014/main" id="{356D87A6-EDD5-2E69-D763-B9824439D4C9}"/>
+                <a16:creationId xmlns:a16="http://schemas.microsoft.com/office/drawing/2014/main" id="{3EC27CB0-A999-3EE6-9202-D0523B37FAC4}"/>
               </a:ext>
             </a:extLst>
           </p:cNvPr>
@@ -4501,7 +4501,7 @@
           <p:cNvPr id="8" name="文本框 7">
             <a:extLst>
               <a:ext uri="{FF2B5EF4-FFF2-40B4-BE49-F238E27FC236}">
-                <a16:creationId xmlns:a16="http://schemas.microsoft.com/office/drawing/2014/main" id="{BA2B34EF-EB09-E0AC-A8E9-2DF73CC959D1}"/>
+                <a16:creationId xmlns:a16="http://schemas.microsoft.com/office/drawing/2014/main" id="{D0A07805-1528-3754-971B-17467DE715D0}"/>
               </a:ext>
             </a:extLst>
           </p:cNvPr>
@@ -4562,7 +4562,7 @@
           <p:cNvPr id="9" name="文本框 8">
             <a:extLst>
               <a:ext uri="{FF2B5EF4-FFF2-40B4-BE49-F238E27FC236}">
-                <a16:creationId xmlns:a16="http://schemas.microsoft.com/office/drawing/2014/main" id="{6A3060CC-B82D-EAFF-9519-9A48694564B0}"/>
+                <a16:creationId xmlns:a16="http://schemas.microsoft.com/office/drawing/2014/main" id="{4E9E0811-8FF5-2991-A7A7-5F3C00B3DE92}"/>
               </a:ext>
             </a:extLst>
           </p:cNvPr>
@@ -4638,7 +4638,7 @@
     </p:spTree>
     <p:extLst>
       <p:ext uri="{BB962C8B-B14F-4D97-AF65-F5344CB8AC3E}">
-        <p14:creationId xmlns:p14="http://schemas.microsoft.com/office/powerpoint/2010/main" val="3225953159"/>
+        <p14:creationId xmlns:p14="http://schemas.microsoft.com/office/powerpoint/2010/main" val="374409321"/>
       </p:ext>
     </p:extLst>
   </p:cSld>
@@ -4670,7 +4670,7 @@
           <p:cNvPr id="2" name="矩形 1">
             <a:extLst>
               <a:ext uri="{FF2B5EF4-FFF2-40B4-BE49-F238E27FC236}">
-                <a16:creationId xmlns:a16="http://schemas.microsoft.com/office/drawing/2014/main" id="{867135B9-E452-455C-14CC-E22B48ADBF86}"/>
+                <a16:creationId xmlns:a16="http://schemas.microsoft.com/office/drawing/2014/main" id="{D87A6B6F-ABA6-F642-1353-0ED43F5DD2A8}"/>
               </a:ext>
             </a:extLst>
           </p:cNvPr>
@@ -4738,7 +4738,7 @@
           <p:cNvPr id="3" name="文本框 2">
             <a:extLst>
               <a:ext uri="{FF2B5EF4-FFF2-40B4-BE49-F238E27FC236}">
-                <a16:creationId xmlns:a16="http://schemas.microsoft.com/office/drawing/2014/main" id="{E93DBFB3-72E5-E16F-FCD7-226E3236E304}"/>
+                <a16:creationId xmlns:a16="http://schemas.microsoft.com/office/drawing/2014/main" id="{15DACE57-4F99-74DA-2584-EE938708C44F}"/>
               </a:ext>
             </a:extLst>
           </p:cNvPr>
@@ -4779,7 +4779,7 @@
           <p:cNvPr id="4" name="文本框 3">
             <a:extLst>
               <a:ext uri="{FF2B5EF4-FFF2-40B4-BE49-F238E27FC236}">
-                <a16:creationId xmlns:a16="http://schemas.microsoft.com/office/drawing/2014/main" id="{FFFB450D-77BC-39B4-195D-DD54FDFA85C8}"/>
+                <a16:creationId xmlns:a16="http://schemas.microsoft.com/office/drawing/2014/main" id="{8C9EE6C5-F57A-AD94-5319-932FFAD0056A}"/>
               </a:ext>
             </a:extLst>
           </p:cNvPr>
@@ -4820,7 +4820,7 @@
           <p:cNvPr id="6" name="图片 5">
             <a:extLst>
               <a:ext uri="{FF2B5EF4-FFF2-40B4-BE49-F238E27FC236}">
-                <a16:creationId xmlns:a16="http://schemas.microsoft.com/office/drawing/2014/main" id="{7C80730E-ADA2-BA2A-6D6D-95302D810385}"/>
+                <a16:creationId xmlns:a16="http://schemas.microsoft.com/office/drawing/2014/main" id="{2DC7FCEF-F877-4276-AD4A-7AC89F2DCC65}"/>
               </a:ext>
             </a:extLst>
           </p:cNvPr>
@@ -4856,7 +4856,7 @@
           <p:cNvPr id="7" name="矩形 6">
             <a:extLst>
               <a:ext uri="{FF2B5EF4-FFF2-40B4-BE49-F238E27FC236}">
-                <a16:creationId xmlns:a16="http://schemas.microsoft.com/office/drawing/2014/main" id="{8B8CF514-7C35-01D0-3F76-33989FE30C6F}"/>
+                <a16:creationId xmlns:a16="http://schemas.microsoft.com/office/drawing/2014/main" id="{04185A51-BB4A-CE30-FDA7-DEE559E292BE}"/>
               </a:ext>
             </a:extLst>
           </p:cNvPr>
@@ -4924,7 +4924,7 @@
           <p:cNvPr id="8" name="文本框 7">
             <a:extLst>
               <a:ext uri="{FF2B5EF4-FFF2-40B4-BE49-F238E27FC236}">
-                <a16:creationId xmlns:a16="http://schemas.microsoft.com/office/drawing/2014/main" id="{9C1C4207-839D-B251-9A39-811ABEF84015}"/>
+                <a16:creationId xmlns:a16="http://schemas.microsoft.com/office/drawing/2014/main" id="{F6A55115-935E-9062-085C-C5DF5B90E99F}"/>
               </a:ext>
             </a:extLst>
           </p:cNvPr>
@@ -4985,7 +4985,7 @@
           <p:cNvPr id="9" name="文本框 8">
             <a:extLst>
               <a:ext uri="{FF2B5EF4-FFF2-40B4-BE49-F238E27FC236}">
-                <a16:creationId xmlns:a16="http://schemas.microsoft.com/office/drawing/2014/main" id="{C26760E4-6F0D-FFC2-2236-584F474A27A6}"/>
+                <a16:creationId xmlns:a16="http://schemas.microsoft.com/office/drawing/2014/main" id="{E5C5941D-BEDA-4DF7-7B98-62F980B04E12}"/>
               </a:ext>
             </a:extLst>
           </p:cNvPr>
@@ -5061,7 +5061,7 @@
     </p:spTree>
     <p:extLst>
       <p:ext uri="{BB962C8B-B14F-4D97-AF65-F5344CB8AC3E}">
-        <p14:creationId xmlns:p14="http://schemas.microsoft.com/office/powerpoint/2010/main" val="2771987746"/>
+        <p14:creationId xmlns:p14="http://schemas.microsoft.com/office/powerpoint/2010/main" val="3777179113"/>
       </p:ext>
     </p:extLst>
   </p:cSld>
@@ -5093,7 +5093,7 @@
           <p:cNvPr id="2" name="矩形 1">
             <a:extLst>
               <a:ext uri="{FF2B5EF4-FFF2-40B4-BE49-F238E27FC236}">
-                <a16:creationId xmlns:a16="http://schemas.microsoft.com/office/drawing/2014/main" id="{FE04197F-1F84-6618-1532-C7C891515D51}"/>
+                <a16:creationId xmlns:a16="http://schemas.microsoft.com/office/drawing/2014/main" id="{324BA89C-7ABD-348F-7B20-CBD7E3D1010F}"/>
               </a:ext>
             </a:extLst>
           </p:cNvPr>
@@ -5161,7 +5161,7 @@
           <p:cNvPr id="3" name="文本框 2">
             <a:extLst>
               <a:ext uri="{FF2B5EF4-FFF2-40B4-BE49-F238E27FC236}">
-                <a16:creationId xmlns:a16="http://schemas.microsoft.com/office/drawing/2014/main" id="{66FAC30C-2F70-2048-5546-0A12003BB3E3}"/>
+                <a16:creationId xmlns:a16="http://schemas.microsoft.com/office/drawing/2014/main" id="{B905B3E2-ED0E-4E58-800B-7D3EAC7DB3D5}"/>
               </a:ext>
             </a:extLst>
           </p:cNvPr>
@@ -5202,7 +5202,7 @@
           <p:cNvPr id="4" name="文本框 3">
             <a:extLst>
               <a:ext uri="{FF2B5EF4-FFF2-40B4-BE49-F238E27FC236}">
-                <a16:creationId xmlns:a16="http://schemas.microsoft.com/office/drawing/2014/main" id="{93AA8B4A-BDF6-BCBF-F7D0-6A07FF0A75B8}"/>
+                <a16:creationId xmlns:a16="http://schemas.microsoft.com/office/drawing/2014/main" id="{EB2177DE-9323-F31B-3358-77E87986F55D}"/>
               </a:ext>
             </a:extLst>
           </p:cNvPr>
@@ -5305,7 +5305,7 @@
           <p:cNvPr id="5" name="矩形 4">
             <a:extLst>
               <a:ext uri="{FF2B5EF4-FFF2-40B4-BE49-F238E27FC236}">
-                <a16:creationId xmlns:a16="http://schemas.microsoft.com/office/drawing/2014/main" id="{2B3C31B7-61ED-3E07-8778-912F7C7C5674}"/>
+                <a16:creationId xmlns:a16="http://schemas.microsoft.com/office/drawing/2014/main" id="{83DA6F48-FD63-9FC9-2CE1-C7EB1EFB75C3}"/>
               </a:ext>
             </a:extLst>
           </p:cNvPr>
@@ -5373,7 +5373,7 @@
           <p:cNvPr id="6" name="文本框 5">
             <a:extLst>
               <a:ext uri="{FF2B5EF4-FFF2-40B4-BE49-F238E27FC236}">
-                <a16:creationId xmlns:a16="http://schemas.microsoft.com/office/drawing/2014/main" id="{17D0433B-EAAB-DA8E-D5B4-C9211129880D}"/>
+                <a16:creationId xmlns:a16="http://schemas.microsoft.com/office/drawing/2014/main" id="{3CD31061-E3C0-9130-0262-4A2D25CF1536}"/>
               </a:ext>
             </a:extLst>
           </p:cNvPr>
@@ -5471,7 +5471,7 @@
           <p:cNvPr id="7" name="文本框 6">
             <a:extLst>
               <a:ext uri="{FF2B5EF4-FFF2-40B4-BE49-F238E27FC236}">
-                <a16:creationId xmlns:a16="http://schemas.microsoft.com/office/drawing/2014/main" id="{592C7BF6-C511-56FF-4410-E87CC8A1B614}"/>
+                <a16:creationId xmlns:a16="http://schemas.microsoft.com/office/drawing/2014/main" id="{4D8D2CC7-98F0-C9D4-F70A-D8BD6B8AEDC0}"/>
               </a:ext>
             </a:extLst>
           </p:cNvPr>
@@ -5547,7 +5547,7 @@
     </p:spTree>
     <p:extLst>
       <p:ext uri="{BB962C8B-B14F-4D97-AF65-F5344CB8AC3E}">
-        <p14:creationId xmlns:p14="http://schemas.microsoft.com/office/powerpoint/2010/main" val="3393826725"/>
+        <p14:creationId xmlns:p14="http://schemas.microsoft.com/office/powerpoint/2010/main" val="2339832129"/>
       </p:ext>
     </p:extLst>
   </p:cSld>
@@ -5579,7 +5579,7 @@
           <p:cNvPr id="2" name="矩形 1">
             <a:extLst>
               <a:ext uri="{FF2B5EF4-FFF2-40B4-BE49-F238E27FC236}">
-                <a16:creationId xmlns:a16="http://schemas.microsoft.com/office/drawing/2014/main" id="{F251D711-0E2F-E01C-A14C-ED435E90F5C3}"/>
+                <a16:creationId xmlns:a16="http://schemas.microsoft.com/office/drawing/2014/main" id="{24D6773E-8A7B-7B9D-BFA5-F434B23B9C21}"/>
               </a:ext>
             </a:extLst>
           </p:cNvPr>
@@ -5647,7 +5647,7 @@
           <p:cNvPr id="3" name="文本框 2">
             <a:extLst>
               <a:ext uri="{FF2B5EF4-FFF2-40B4-BE49-F238E27FC236}">
-                <a16:creationId xmlns:a16="http://schemas.microsoft.com/office/drawing/2014/main" id="{00B045A2-43B7-F244-DDBD-B4E97E36E9B9}"/>
+                <a16:creationId xmlns:a16="http://schemas.microsoft.com/office/drawing/2014/main" id="{3523BBBE-8B53-83F9-A569-4F82A377B53A}"/>
               </a:ext>
             </a:extLst>
           </p:cNvPr>
@@ -5688,7 +5688,7 @@
           <p:cNvPr id="4" name="文本框 3">
             <a:extLst>
               <a:ext uri="{FF2B5EF4-FFF2-40B4-BE49-F238E27FC236}">
-                <a16:creationId xmlns:a16="http://schemas.microsoft.com/office/drawing/2014/main" id="{51ED7EBF-83BF-EB89-3484-C7B6291E03CB}"/>
+                <a16:creationId xmlns:a16="http://schemas.microsoft.com/office/drawing/2014/main" id="{9AF850C0-FB0A-3AC0-F567-F11FEE2790ED}"/>
               </a:ext>
             </a:extLst>
           </p:cNvPr>
@@ -5698,7 +5698,7 @@
         <p:spPr>
           <a:xfrm>
             <a:off x="825500" y="1676400"/>
-            <a:ext cx="6350000" cy="646331"/>
+            <a:ext cx="6350000" cy="1200329"/>
           </a:xfrm>
           <a:prstGeom prst="rect">
             <a:avLst/>
@@ -5719,7 +5719,7 @@
                 <a:latin typeface="Aptos" panose="020B0004020202020204" pitchFamily="34" charset="0"/>
                 <a:ea typeface="Microsoft YaHei" panose="020B0503020204020204" pitchFamily="34" charset="-122"/>
               </a:rPr>
-              <a:t>真实 </a:t>
+              <a:t>默认卷 </a:t>
             </a:r>
             <a:r>
               <a:rPr lang="en-US" altLang="zh-CN">
@@ -5729,7 +5729,7 @@
                 <a:latin typeface="Aptos" panose="020B0004020202020204" pitchFamily="34" charset="0"/>
                 <a:ea typeface="Microsoft YaHei" panose="020B0503020204020204" pitchFamily="34" charset="-122"/>
               </a:rPr>
-              <a:t>Provider </a:t>
+              <a:t>127.0.0.1:8080 </a:t>
             </a:r>
             <a:r>
               <a:rPr lang="zh-CN" altLang="en-US">
@@ -5739,7 +5739,7 @@
                 <a:latin typeface="Aptos" panose="020B0004020202020204" pitchFamily="34" charset="0"/>
                 <a:ea typeface="Microsoft YaHei" panose="020B0503020204020204" pitchFamily="34" charset="-122"/>
               </a:rPr>
-              <a:t>三次评测是必需项。独立黄金卷未配置 </a:t>
+              <a:t>已真实调用 </a:t>
             </a:r>
             <a:r>
               <a:rPr lang="en-US" altLang="zh-CN">
@@ -5749,7 +5749,7 @@
                 <a:latin typeface="Aptos" panose="020B0004020202020204" pitchFamily="34" charset="0"/>
                 <a:ea typeface="Microsoft YaHei" panose="020B0503020204020204" pitchFamily="34" charset="-122"/>
               </a:rPr>
-              <a:t>Provider/Agent</a:t>
+              <a:t>Provider</a:t>
             </a:r>
             <a:r>
               <a:rPr lang="zh-CN" altLang="en-US">
@@ -5759,7 +5759,7 @@
                 <a:latin typeface="Aptos" panose="020B0004020202020204" pitchFamily="34" charset="0"/>
                 <a:ea typeface="Microsoft YaHei" panose="020B0503020204020204" pitchFamily="34" charset="-122"/>
               </a:rPr>
-              <a:t>，故未填写 </a:t>
+              <a:t>：</a:t>
             </a:r>
             <a:r>
               <a:rPr lang="en-US" altLang="zh-CN">
@@ -5769,7 +5769,7 @@
                 <a:latin typeface="Aptos" panose="020B0004020202020204" pitchFamily="34" charset="0"/>
                 <a:ea typeface="Microsoft YaHei" panose="020B0503020204020204" pitchFamily="34" charset="-122"/>
               </a:rPr>
-              <a:t>pass@1</a:t>
+              <a:t>A 2/3</a:t>
             </a:r>
             <a:r>
               <a:rPr lang="zh-CN" altLang="en-US">
@@ -5779,7 +5779,7 @@
                 <a:latin typeface="Aptos" panose="020B0004020202020204" pitchFamily="34" charset="0"/>
                 <a:ea typeface="Microsoft YaHei" panose="020B0503020204020204" pitchFamily="34" charset="-122"/>
               </a:rPr>
-              <a:t>、成本或 </a:t>
+              <a:t>，</a:t>
             </a:r>
             <a:r>
               <a:rPr lang="en-US" altLang="zh-CN">
@@ -5789,7 +5789,7 @@
                 <a:latin typeface="Aptos" panose="020B0004020202020204" pitchFamily="34" charset="0"/>
                 <a:ea typeface="Microsoft YaHei" panose="020B0503020204020204" pitchFamily="34" charset="-122"/>
               </a:rPr>
-              <a:t>Token</a:t>
+              <a:t>B 3/3</a:t>
             </a:r>
             <a:r>
               <a:rPr lang="zh-CN" altLang="en-US">
@@ -5799,9 +5799,81 @@
                 <a:latin typeface="Aptos" panose="020B0004020202020204" pitchFamily="34" charset="0"/>
                 <a:ea typeface="Microsoft YaHei" panose="020B0503020204020204" pitchFamily="34" charset="-122"/>
               </a:rPr>
+              <a:t>；</a:t>
+            </a:r>
+            <a:r>
+              <a:rPr lang="en-US" altLang="zh-CN">
+                <a:solidFill>
+                  <a:srgbClr val="323232"/>
+                </a:solidFill>
+                <a:latin typeface="Aptos" panose="020B0004020202020204" pitchFamily="34" charset="0"/>
+                <a:ea typeface="Microsoft YaHei" panose="020B0503020204020204" pitchFamily="34" charset="-122"/>
+              </a:rPr>
+              <a:t>C </a:t>
+            </a:r>
+            <a:r>
+              <a:rPr lang="zh-CN" altLang="en-US">
+                <a:solidFill>
+                  <a:srgbClr val="323232"/>
+                </a:solidFill>
+                <a:latin typeface="Aptos" panose="020B0004020202020204" pitchFamily="34" charset="0"/>
+                <a:ea typeface="Microsoft YaHei" panose="020B0503020204020204" pitchFamily="34" charset="-122"/>
+              </a:rPr>
+              <a:t>修复后 </a:t>
+            </a:r>
+            <a:r>
+              <a:rPr lang="en-US" altLang="zh-CN">
+                <a:solidFill>
+                  <a:srgbClr val="323232"/>
+                </a:solidFill>
+                <a:latin typeface="Aptos" panose="020B0004020202020204" pitchFamily="34" charset="0"/>
+                <a:ea typeface="Microsoft YaHei" panose="020B0503020204020204" pitchFamily="34" charset="-122"/>
+              </a:rPr>
+              <a:t>9/9</a:t>
+            </a:r>
+            <a:r>
+              <a:rPr lang="zh-CN" altLang="en-US">
+                <a:solidFill>
+                  <a:srgbClr val="323232"/>
+                </a:solidFill>
+                <a:latin typeface="Aptos" panose="020B0004020202020204" pitchFamily="34" charset="0"/>
+                <a:ea typeface="Microsoft YaHei" panose="020B0503020204020204" pitchFamily="34" charset="-122"/>
+              </a:rPr>
               <a:t>。</a:t>
             </a:r>
           </a:p>
+          <a:p>
+            <a:r>
+              <a:rPr lang="zh-CN" altLang="en-US">
+                <a:solidFill>
+                  <a:srgbClr val="323232"/>
+                </a:solidFill>
+                <a:latin typeface="Aptos" panose="020B0004020202020204" pitchFamily="34" charset="0"/>
+                <a:ea typeface="Microsoft YaHei" panose="020B0503020204020204" pitchFamily="34" charset="-122"/>
+              </a:rPr>
+              <a:t>独立黄金卷尚未配置 </a:t>
+            </a:r>
+            <a:r>
+              <a:rPr lang="en-US" altLang="zh-CN">
+                <a:solidFill>
+                  <a:srgbClr val="323232"/>
+                </a:solidFill>
+                <a:latin typeface="Aptos" panose="020B0004020202020204" pitchFamily="34" charset="0"/>
+                <a:ea typeface="Microsoft YaHei" panose="020B0503020204020204" pitchFamily="34" charset="-122"/>
+              </a:rPr>
+              <a:t>Provider</a:t>
+            </a:r>
+            <a:r>
+              <a:rPr lang="zh-CN" altLang="en-US">
+                <a:solidFill>
+                  <a:srgbClr val="323232"/>
+                </a:solidFill>
+                <a:latin typeface="Aptos" panose="020B0004020202020204" pitchFamily="34" charset="0"/>
+                <a:ea typeface="Microsoft YaHei" panose="020B0503020204020204" pitchFamily="34" charset="-122"/>
+              </a:rPr>
+              <a:t>，不将默认卷结果冒充独立卷验收。</a:t>
+            </a:r>
+          </a:p>
         </p:txBody>
       </p:sp>
       <p:sp>
@@ -5809,7 +5881,7 @@
           <p:cNvPr id="5" name="矩形 4">
             <a:extLst>
               <a:ext uri="{FF2B5EF4-FFF2-40B4-BE49-F238E27FC236}">
-                <a16:creationId xmlns:a16="http://schemas.microsoft.com/office/drawing/2014/main" id="{BC935CCC-256E-F5DC-0BD1-7556F078D2E2}"/>
+                <a16:creationId xmlns:a16="http://schemas.microsoft.com/office/drawing/2014/main" id="{CB330BC2-64E2-A439-BCCB-29F5F4D15451}"/>
               </a:ext>
             </a:extLst>
           </p:cNvPr>
@@ -5877,7 +5949,7 @@
           <p:cNvPr id="6" name="文本框 5">
             <a:extLst>
               <a:ext uri="{FF2B5EF4-FFF2-40B4-BE49-F238E27FC236}">
-                <a16:creationId xmlns:a16="http://schemas.microsoft.com/office/drawing/2014/main" id="{F1FDF996-173B-CFA2-E65D-A76883EB145E}"/>
+                <a16:creationId xmlns:a16="http://schemas.microsoft.com/office/drawing/2014/main" id="{FE304BC7-B6A8-CAFA-D655-A58651AEC43C}"/>
               </a:ext>
             </a:extLst>
           </p:cNvPr>
@@ -5908,7 +5980,7 @@
                 <a:latin typeface="Aptos" panose="020B0004020202020204" pitchFamily="34" charset="0"/>
                 <a:ea typeface="Microsoft YaHei" panose="020B0503020204020204" pitchFamily="34" charset="-122"/>
               </a:rPr>
-              <a:t>证据：</a:t>
+              <a:t>证据：脱敏 </a:t>
             </a:r>
             <a:r>
               <a:rPr lang="en-US" altLang="zh-CN" sz="1100">
@@ -5918,7 +5990,7 @@
                 <a:latin typeface="Aptos" panose="020B0004020202020204" pitchFamily="34" charset="0"/>
                 <a:ea typeface="Microsoft YaHei" panose="020B0503020204020204" pitchFamily="34" charset="-122"/>
               </a:rPr>
-              <a:t>/setup/status</a:t>
+              <a:t>Run </a:t>
             </a:r>
             <a:r>
               <a:rPr lang="zh-CN" altLang="en-US" sz="1100">
@@ -5928,7 +6000,7 @@
                 <a:latin typeface="Aptos" panose="020B0004020202020204" pitchFamily="34" charset="0"/>
                 <a:ea typeface="Microsoft YaHei" panose="020B0503020204020204" pitchFamily="34" charset="-122"/>
               </a:rPr>
-              <a:t>；测试与评测报告</a:t>
+              <a:t>摘要；测试与评测报告</a:t>
             </a:r>
           </a:p>
         </p:txBody>
@@ -5938,7 +6010,7 @@
           <p:cNvPr id="7" name="文本框 6">
             <a:extLst>
               <a:ext uri="{FF2B5EF4-FFF2-40B4-BE49-F238E27FC236}">
-                <a16:creationId xmlns:a16="http://schemas.microsoft.com/office/drawing/2014/main" id="{93AFCA6C-8C01-7811-57CC-F9DCA249C71A}"/>
+                <a16:creationId xmlns:a16="http://schemas.microsoft.com/office/drawing/2014/main" id="{AC9D7BCF-631F-68C1-9ABE-6948F9B27071}"/>
               </a:ext>
             </a:extLst>
           </p:cNvPr>
@@ -6014,7 +6086,7 @@
     </p:spTree>
     <p:extLst>
       <p:ext uri="{BB962C8B-B14F-4D97-AF65-F5344CB8AC3E}">
-        <p14:creationId xmlns:p14="http://schemas.microsoft.com/office/powerpoint/2010/main" val="2136864274"/>
+        <p14:creationId xmlns:p14="http://schemas.microsoft.com/office/powerpoint/2010/main" val="1835774853"/>
       </p:ext>
     </p:extLst>
   </p:cSld>
@@ -6046,7 +6118,7 @@
           <p:cNvPr id="2" name="矩形 1">
             <a:extLst>
               <a:ext uri="{FF2B5EF4-FFF2-40B4-BE49-F238E27FC236}">
-                <a16:creationId xmlns:a16="http://schemas.microsoft.com/office/drawing/2014/main" id="{48DE8ADC-AD9F-F8A5-7BA0-DCA403EB5459}"/>
+                <a16:creationId xmlns:a16="http://schemas.microsoft.com/office/drawing/2014/main" id="{3703063C-897F-1CE4-2503-32BDFDFB8B84}"/>
               </a:ext>
             </a:extLst>
           </p:cNvPr>
@@ -6114,7 +6186,7 @@
           <p:cNvPr id="3" name="文本框 2">
             <a:extLst>
               <a:ext uri="{FF2B5EF4-FFF2-40B4-BE49-F238E27FC236}">
-                <a16:creationId xmlns:a16="http://schemas.microsoft.com/office/drawing/2014/main" id="{8E56BF8C-E9FF-E288-DCFD-F318BB643D92}"/>
+                <a16:creationId xmlns:a16="http://schemas.microsoft.com/office/drawing/2014/main" id="{67565A1B-ABAF-FBE8-3BDB-64342EDC6CD2}"/>
               </a:ext>
             </a:extLst>
           </p:cNvPr>
@@ -6155,7 +6227,7 @@
           <p:cNvPr id="4" name="文本框 3">
             <a:extLst>
               <a:ext uri="{FF2B5EF4-FFF2-40B4-BE49-F238E27FC236}">
-                <a16:creationId xmlns:a16="http://schemas.microsoft.com/office/drawing/2014/main" id="{3109A42D-D264-5BC6-3B3B-3B6903CCC21A}"/>
+                <a16:creationId xmlns:a16="http://schemas.microsoft.com/office/drawing/2014/main" id="{52DA43FA-0CDF-6401-58A2-5EBDDF3768EC}"/>
               </a:ext>
             </a:extLst>
           </p:cNvPr>
@@ -6218,7 +6290,7 @@
                 <a:latin typeface="Aptos" panose="020B0004020202020204" pitchFamily="34" charset="0"/>
                 <a:ea typeface="Microsoft YaHei" panose="020B0503020204020204" pitchFamily="34" charset="-122"/>
               </a:rPr>
-              <a:t>配置真实 </a:t>
+              <a:t>独立黄金卷需配置真实 </a:t>
             </a:r>
             <a:r>
               <a:rPr lang="en-US" altLang="zh-CN">
@@ -6238,7 +6310,7 @@
                 <a:latin typeface="Aptos" panose="020B0004020202020204" pitchFamily="34" charset="0"/>
                 <a:ea typeface="Microsoft YaHei" panose="020B0503020204020204" pitchFamily="34" charset="-122"/>
               </a:rPr>
-              <a:t>后按同一证据链补齐三次数据。</a:t>
+              <a:t>后按同一证据链复测。</a:t>
             </a:r>
           </a:p>
         </p:txBody>
@@ -6248,7 +6320,7 @@
           <p:cNvPr id="5" name="矩形 4">
             <a:extLst>
               <a:ext uri="{FF2B5EF4-FFF2-40B4-BE49-F238E27FC236}">
-                <a16:creationId xmlns:a16="http://schemas.microsoft.com/office/drawing/2014/main" id="{73EE0A0F-09EC-876E-4A57-30B63A8BF511}"/>
+                <a16:creationId xmlns:a16="http://schemas.microsoft.com/office/drawing/2014/main" id="{1CA9DF79-DA9B-01DC-40F2-1D7282B368AE}"/>
               </a:ext>
             </a:extLst>
           </p:cNvPr>
@@ -6316,7 +6388,7 @@
           <p:cNvPr id="6" name="文本框 5">
             <a:extLst>
               <a:ext uri="{FF2B5EF4-FFF2-40B4-BE49-F238E27FC236}">
-                <a16:creationId xmlns:a16="http://schemas.microsoft.com/office/drawing/2014/main" id="{030F0761-6E0D-A1EA-CD8D-684088DFF7FB}"/>
+                <a16:creationId xmlns:a16="http://schemas.microsoft.com/office/drawing/2014/main" id="{64EE5D0B-E9BB-49D6-A851-74D2CC56EEAB}"/>
               </a:ext>
             </a:extLst>
           </p:cNvPr>
@@ -6377,7 +6449,7 @@
           <p:cNvPr id="7" name="文本框 6">
             <a:extLst>
               <a:ext uri="{FF2B5EF4-FFF2-40B4-BE49-F238E27FC236}">
-                <a16:creationId xmlns:a16="http://schemas.microsoft.com/office/drawing/2014/main" id="{9081035B-0CC6-1DF4-32DA-585AE353B01E}"/>
+                <a16:creationId xmlns:a16="http://schemas.microsoft.com/office/drawing/2014/main" id="{8E60C544-8F6E-D1CA-625D-2D584613D3C8}"/>
               </a:ext>
             </a:extLst>
           </p:cNvPr>
@@ -6453,7 +6525,7 @@
     </p:spTree>
     <p:extLst>
       <p:ext uri="{BB962C8B-B14F-4D97-AF65-F5344CB8AC3E}">
-        <p14:creationId xmlns:p14="http://schemas.microsoft.com/office/powerpoint/2010/main" val="3854343112"/>
+        <p14:creationId xmlns:p14="http://schemas.microsoft.com/office/powerpoint/2010/main" val="1182083956"/>
       </p:ext>
     </p:extLst>
   </p:cSld>
@@ -6485,7 +6557,7 @@
           <p:cNvPr id="2" name="矩形 1">
             <a:extLst>
               <a:ext uri="{FF2B5EF4-FFF2-40B4-BE49-F238E27FC236}">
-                <a16:creationId xmlns:a16="http://schemas.microsoft.com/office/drawing/2014/main" id="{722C2FAB-F06D-64EC-D09C-A12378F0A013}"/>
+                <a16:creationId xmlns:a16="http://schemas.microsoft.com/office/drawing/2014/main" id="{751138F4-7F70-0157-C318-D5D4799F34FD}"/>
               </a:ext>
             </a:extLst>
           </p:cNvPr>
@@ -6553,7 +6625,7 @@
           <p:cNvPr id="3" name="文本框 2">
             <a:extLst>
               <a:ext uri="{FF2B5EF4-FFF2-40B4-BE49-F238E27FC236}">
-                <a16:creationId xmlns:a16="http://schemas.microsoft.com/office/drawing/2014/main" id="{B60FADBF-C8C7-8837-E830-785E011015ED}"/>
+                <a16:creationId xmlns:a16="http://schemas.microsoft.com/office/drawing/2014/main" id="{693ADC80-DF6E-4FA9-CE67-6E3F20F1E6B2}"/>
               </a:ext>
             </a:extLst>
           </p:cNvPr>
@@ -6594,7 +6666,7 @@
           <p:cNvPr id="4" name="文本框 3">
             <a:extLst>
               <a:ext uri="{FF2B5EF4-FFF2-40B4-BE49-F238E27FC236}">
-                <a16:creationId xmlns:a16="http://schemas.microsoft.com/office/drawing/2014/main" id="{73CA64E1-78E1-51DC-2C98-87DBCD97FB36}"/>
+                <a16:creationId xmlns:a16="http://schemas.microsoft.com/office/drawing/2014/main" id="{DBA2A53D-D609-67A7-7D4F-8E68FC114FA4}"/>
               </a:ext>
             </a:extLst>
           </p:cNvPr>
@@ -6659,7 +6731,7 @@
           <p:cNvPr id="5" name="矩形 4">
             <a:extLst>
               <a:ext uri="{FF2B5EF4-FFF2-40B4-BE49-F238E27FC236}">
-                <a16:creationId xmlns:a16="http://schemas.microsoft.com/office/drawing/2014/main" id="{FCF165A0-A30A-17B2-1854-7851DD01236D}"/>
+                <a16:creationId xmlns:a16="http://schemas.microsoft.com/office/drawing/2014/main" id="{3B23EAD7-6E57-61A4-AEA5-88CF2A26D328}"/>
               </a:ext>
             </a:extLst>
           </p:cNvPr>
@@ -6727,7 +6799,7 @@
           <p:cNvPr id="6" name="文本框 5">
             <a:extLst>
               <a:ext uri="{FF2B5EF4-FFF2-40B4-BE49-F238E27FC236}">
-                <a16:creationId xmlns:a16="http://schemas.microsoft.com/office/drawing/2014/main" id="{E6D25F11-3603-55EC-6C9A-4850C4E77B38}"/>
+                <a16:creationId xmlns:a16="http://schemas.microsoft.com/office/drawing/2014/main" id="{CBC3251C-1C58-6DFB-CE30-0055E0F99D4F}"/>
               </a:ext>
             </a:extLst>
           </p:cNvPr>
@@ -6768,7 +6840,7 @@
           <p:cNvPr id="7" name="文本框 6">
             <a:extLst>
               <a:ext uri="{FF2B5EF4-FFF2-40B4-BE49-F238E27FC236}">
-                <a16:creationId xmlns:a16="http://schemas.microsoft.com/office/drawing/2014/main" id="{62083356-FF51-A9E8-062F-B30D2DBF5121}"/>
+                <a16:creationId xmlns:a16="http://schemas.microsoft.com/office/drawing/2014/main" id="{18E37C66-FA13-C753-F8D6-7367D703F064}"/>
               </a:ext>
             </a:extLst>
           </p:cNvPr>
@@ -6844,7 +6916,7 @@
     </p:spTree>
     <p:extLst>
       <p:ext uri="{BB962C8B-B14F-4D97-AF65-F5344CB8AC3E}">
-        <p14:creationId xmlns:p14="http://schemas.microsoft.com/office/powerpoint/2010/main" val="4184277881"/>
+        <p14:creationId xmlns:p14="http://schemas.microsoft.com/office/powerpoint/2010/main" val="3823269198"/>
       </p:ext>
     </p:extLst>
   </p:cSld>
@@ -6876,7 +6948,7 @@
           <p:cNvPr id="2" name="矩形 1">
             <a:extLst>
               <a:ext uri="{FF2B5EF4-FFF2-40B4-BE49-F238E27FC236}">
-                <a16:creationId xmlns:a16="http://schemas.microsoft.com/office/drawing/2014/main" id="{469ADC2C-822C-5C3E-B770-33F5CF8247BA}"/>
+                <a16:creationId xmlns:a16="http://schemas.microsoft.com/office/drawing/2014/main" id="{69A628A4-E787-1104-0975-D27E45B33B48}"/>
               </a:ext>
             </a:extLst>
           </p:cNvPr>
@@ -6944,7 +7016,7 @@
           <p:cNvPr id="3" name="文本框 2">
             <a:extLst>
               <a:ext uri="{FF2B5EF4-FFF2-40B4-BE49-F238E27FC236}">
-                <a16:creationId xmlns:a16="http://schemas.microsoft.com/office/drawing/2014/main" id="{27397781-83CE-50CC-26C2-0CEE496DC20A}"/>
+                <a16:creationId xmlns:a16="http://schemas.microsoft.com/office/drawing/2014/main" id="{F272F717-0C3A-0989-6DAE-E015332E272B}"/>
               </a:ext>
             </a:extLst>
           </p:cNvPr>
@@ -6985,7 +7057,7 @@
           <p:cNvPr id="4" name="文本框 3">
             <a:extLst>
               <a:ext uri="{FF2B5EF4-FFF2-40B4-BE49-F238E27FC236}">
-                <a16:creationId xmlns:a16="http://schemas.microsoft.com/office/drawing/2014/main" id="{3F643274-0023-7810-5417-EC5F94D346D8}"/>
+                <a16:creationId xmlns:a16="http://schemas.microsoft.com/office/drawing/2014/main" id="{F849426D-6164-85BF-2E0C-E3B56DD8EEE8}"/>
               </a:ext>
             </a:extLst>
           </p:cNvPr>
@@ -7143,7 +7215,7 @@
           <p:cNvPr id="5" name="矩形 4">
             <a:extLst>
               <a:ext uri="{FF2B5EF4-FFF2-40B4-BE49-F238E27FC236}">
-                <a16:creationId xmlns:a16="http://schemas.microsoft.com/office/drawing/2014/main" id="{1D2223DD-1272-DBC3-66DD-67400831DBF2}"/>
+                <a16:creationId xmlns:a16="http://schemas.microsoft.com/office/drawing/2014/main" id="{0945B405-27E2-E28A-F1F8-B9B2724F95B7}"/>
               </a:ext>
             </a:extLst>
           </p:cNvPr>
@@ -7211,7 +7283,7 @@
           <p:cNvPr id="6" name="文本框 5">
             <a:extLst>
               <a:ext uri="{FF2B5EF4-FFF2-40B4-BE49-F238E27FC236}">
-                <a16:creationId xmlns:a16="http://schemas.microsoft.com/office/drawing/2014/main" id="{EFBA5E9C-28EE-E1D6-BF68-CE4AB50A9648}"/>
+                <a16:creationId xmlns:a16="http://schemas.microsoft.com/office/drawing/2014/main" id="{16FD424C-DFC6-7583-BD5B-9A2871AE6767}"/>
               </a:ext>
             </a:extLst>
           </p:cNvPr>
@@ -7309,7 +7381,7 @@
           <p:cNvPr id="7" name="文本框 6">
             <a:extLst>
               <a:ext uri="{FF2B5EF4-FFF2-40B4-BE49-F238E27FC236}">
-                <a16:creationId xmlns:a16="http://schemas.microsoft.com/office/drawing/2014/main" id="{5A39E495-B72F-6B63-F42E-F1EC74CB84F7}"/>
+                <a16:creationId xmlns:a16="http://schemas.microsoft.com/office/drawing/2014/main" id="{BA9933CF-83EF-98CE-DD06-82DC777A75A5}"/>
               </a:ext>
             </a:extLst>
           </p:cNvPr>
@@ -7385,7 +7457,7 @@
     </p:spTree>
     <p:extLst>
       <p:ext uri="{BB962C8B-B14F-4D97-AF65-F5344CB8AC3E}">
-        <p14:creationId xmlns:p14="http://schemas.microsoft.com/office/powerpoint/2010/main" val="2619947548"/>
+        <p14:creationId xmlns:p14="http://schemas.microsoft.com/office/powerpoint/2010/main" val="1147585503"/>
       </p:ext>
     </p:extLst>
   </p:cSld>
@@ -7417,7 +7489,7 @@
           <p:cNvPr id="2" name="矩形 1">
             <a:extLst>
               <a:ext uri="{FF2B5EF4-FFF2-40B4-BE49-F238E27FC236}">
-                <a16:creationId xmlns:a16="http://schemas.microsoft.com/office/drawing/2014/main" id="{AF83B444-4118-0755-F5FE-2F8139A7CA0C}"/>
+                <a16:creationId xmlns:a16="http://schemas.microsoft.com/office/drawing/2014/main" id="{2FB51B74-AF2A-CB54-801F-CC005B320F24}"/>
               </a:ext>
             </a:extLst>
           </p:cNvPr>
@@ -7485,7 +7557,7 @@
           <p:cNvPr id="3" name="文本框 2">
             <a:extLst>
               <a:ext uri="{FF2B5EF4-FFF2-40B4-BE49-F238E27FC236}">
-                <a16:creationId xmlns:a16="http://schemas.microsoft.com/office/drawing/2014/main" id="{1DAC3E42-E77E-2B27-1FBC-772298C25C31}"/>
+                <a16:creationId xmlns:a16="http://schemas.microsoft.com/office/drawing/2014/main" id="{F664792C-E85A-BA80-46FE-2B63CFC5C347}"/>
               </a:ext>
             </a:extLst>
           </p:cNvPr>
@@ -7546,7 +7618,7 @@
           <p:cNvPr id="4" name="文本框 3">
             <a:extLst>
               <a:ext uri="{FF2B5EF4-FFF2-40B4-BE49-F238E27FC236}">
-                <a16:creationId xmlns:a16="http://schemas.microsoft.com/office/drawing/2014/main" id="{F0F73858-9D53-0AD5-F6B8-2660AF8E77E2}"/>
+                <a16:creationId xmlns:a16="http://schemas.microsoft.com/office/drawing/2014/main" id="{61318338-F3D1-4AA7-93CC-E5047B86534B}"/>
               </a:ext>
             </a:extLst>
           </p:cNvPr>
@@ -7659,7 +7731,7 @@
           <p:cNvPr id="5" name="矩形 4">
             <a:extLst>
               <a:ext uri="{FF2B5EF4-FFF2-40B4-BE49-F238E27FC236}">
-                <a16:creationId xmlns:a16="http://schemas.microsoft.com/office/drawing/2014/main" id="{63093056-0AD7-1901-232F-0460B2BFFAE2}"/>
+                <a16:creationId xmlns:a16="http://schemas.microsoft.com/office/drawing/2014/main" id="{1B02566E-1EE1-A61E-F6F8-AE3A459E5EA2}"/>
               </a:ext>
             </a:extLst>
           </p:cNvPr>
@@ -7727,7 +7799,7 @@
           <p:cNvPr id="6" name="文本框 5">
             <a:extLst>
               <a:ext uri="{FF2B5EF4-FFF2-40B4-BE49-F238E27FC236}">
-                <a16:creationId xmlns:a16="http://schemas.microsoft.com/office/drawing/2014/main" id="{DA1E66C3-20D2-A555-9279-0896E5E53B9C}"/>
+                <a16:creationId xmlns:a16="http://schemas.microsoft.com/office/drawing/2014/main" id="{29B0BF2A-7CB8-1E5E-EE1B-FE775587A4FF}"/>
               </a:ext>
             </a:extLst>
           </p:cNvPr>
@@ -7865,7 +7937,7 @@
           <p:cNvPr id="7" name="文本框 6">
             <a:extLst>
               <a:ext uri="{FF2B5EF4-FFF2-40B4-BE49-F238E27FC236}">
-                <a16:creationId xmlns:a16="http://schemas.microsoft.com/office/drawing/2014/main" id="{BF2DEBF5-BBA4-51C7-1808-C518424A6433}"/>
+                <a16:creationId xmlns:a16="http://schemas.microsoft.com/office/drawing/2014/main" id="{4081B61A-4E07-5F41-D406-1B9F578D13F7}"/>
               </a:ext>
             </a:extLst>
           </p:cNvPr>
@@ -7941,7 +8013,7 @@
     </p:spTree>
     <p:extLst>
       <p:ext uri="{BB962C8B-B14F-4D97-AF65-F5344CB8AC3E}">
-        <p14:creationId xmlns:p14="http://schemas.microsoft.com/office/powerpoint/2010/main" val="1019910706"/>
+        <p14:creationId xmlns:p14="http://schemas.microsoft.com/office/powerpoint/2010/main" val="3805862217"/>
       </p:ext>
     </p:extLst>
   </p:cSld>
@@ -7973,7 +8045,7 @@
           <p:cNvPr id="2" name="矩形 1">
             <a:extLst>
               <a:ext uri="{FF2B5EF4-FFF2-40B4-BE49-F238E27FC236}">
-                <a16:creationId xmlns:a16="http://schemas.microsoft.com/office/drawing/2014/main" id="{0D0CF71B-7E39-4AAC-0A64-682CE364083D}"/>
+                <a16:creationId xmlns:a16="http://schemas.microsoft.com/office/drawing/2014/main" id="{27D78C1F-C569-0AAD-B3FE-F4D865FA7BD6}"/>
               </a:ext>
             </a:extLst>
           </p:cNvPr>
@@ -8041,7 +8113,7 @@
           <p:cNvPr id="3" name="文本框 2">
             <a:extLst>
               <a:ext uri="{FF2B5EF4-FFF2-40B4-BE49-F238E27FC236}">
-                <a16:creationId xmlns:a16="http://schemas.microsoft.com/office/drawing/2014/main" id="{C195102B-900F-701B-F2A9-65170D21D82A}"/>
+                <a16:creationId xmlns:a16="http://schemas.microsoft.com/office/drawing/2014/main" id="{A92A5CB4-D417-0E78-422B-4C2C9EF3EDD8}"/>
               </a:ext>
             </a:extLst>
           </p:cNvPr>
@@ -8082,7 +8154,7 @@
           <p:cNvPr id="4" name="文本框 3">
             <a:extLst>
               <a:ext uri="{FF2B5EF4-FFF2-40B4-BE49-F238E27FC236}">
-                <a16:creationId xmlns:a16="http://schemas.microsoft.com/office/drawing/2014/main" id="{9D5F8CB5-F6BF-4CFA-47DC-9D5E462175DE}"/>
+                <a16:creationId xmlns:a16="http://schemas.microsoft.com/office/drawing/2014/main" id="{2A11D1CA-1F31-D289-5DFE-7A4A941CAE01}"/>
               </a:ext>
             </a:extLst>
           </p:cNvPr>
@@ -8245,7 +8317,7 @@
           <p:cNvPr id="5" name="矩形 4">
             <a:extLst>
               <a:ext uri="{FF2B5EF4-FFF2-40B4-BE49-F238E27FC236}">
-                <a16:creationId xmlns:a16="http://schemas.microsoft.com/office/drawing/2014/main" id="{35AD8B57-D25E-3253-A9DD-5E892510C46F}"/>
+                <a16:creationId xmlns:a16="http://schemas.microsoft.com/office/drawing/2014/main" id="{1829478F-BF48-D320-7F84-61C9E2EE4E0F}"/>
               </a:ext>
             </a:extLst>
           </p:cNvPr>
@@ -8313,7 +8385,7 @@
           <p:cNvPr id="6" name="文本框 5">
             <a:extLst>
               <a:ext uri="{FF2B5EF4-FFF2-40B4-BE49-F238E27FC236}">
-                <a16:creationId xmlns:a16="http://schemas.microsoft.com/office/drawing/2014/main" id="{A12B48B5-12D2-9432-BD22-287CE67C8CD0}"/>
+                <a16:creationId xmlns:a16="http://schemas.microsoft.com/office/drawing/2014/main" id="{C2AB5018-C4B9-E3BE-6C4E-BA813983197D}"/>
               </a:ext>
             </a:extLst>
           </p:cNvPr>
@@ -8394,7 +8466,7 @@
           <p:cNvPr id="7" name="文本框 6">
             <a:extLst>
               <a:ext uri="{FF2B5EF4-FFF2-40B4-BE49-F238E27FC236}">
-                <a16:creationId xmlns:a16="http://schemas.microsoft.com/office/drawing/2014/main" id="{7EF9E7C0-7310-13A8-7117-AC7598B9DE3E}"/>
+                <a16:creationId xmlns:a16="http://schemas.microsoft.com/office/drawing/2014/main" id="{6B63459D-1BB6-21F3-8FD6-4B9B0D200119}"/>
               </a:ext>
             </a:extLst>
           </p:cNvPr>
@@ -8470,7 +8542,7 @@
     </p:spTree>
     <p:extLst>
       <p:ext uri="{BB962C8B-B14F-4D97-AF65-F5344CB8AC3E}">
-        <p14:creationId xmlns:p14="http://schemas.microsoft.com/office/powerpoint/2010/main" val="2211292424"/>
+        <p14:creationId xmlns:p14="http://schemas.microsoft.com/office/powerpoint/2010/main" val="40910604"/>
       </p:ext>
     </p:extLst>
   </p:cSld>
@@ -8502,7 +8574,7 @@
           <p:cNvPr id="2" name="矩形 1">
             <a:extLst>
               <a:ext uri="{FF2B5EF4-FFF2-40B4-BE49-F238E27FC236}">
-                <a16:creationId xmlns:a16="http://schemas.microsoft.com/office/drawing/2014/main" id="{13B7FDEB-CB0D-2A31-B084-5D157C30D42A}"/>
+                <a16:creationId xmlns:a16="http://schemas.microsoft.com/office/drawing/2014/main" id="{546E2696-12A1-98F5-9EF3-F1DA2D6F452B}"/>
               </a:ext>
             </a:extLst>
           </p:cNvPr>
@@ -8570,7 +8642,7 @@
           <p:cNvPr id="3" name="文本框 2">
             <a:extLst>
               <a:ext uri="{FF2B5EF4-FFF2-40B4-BE49-F238E27FC236}">
-                <a16:creationId xmlns:a16="http://schemas.microsoft.com/office/drawing/2014/main" id="{061357D9-608C-D4A7-1B78-7966F04E0FEA}"/>
+                <a16:creationId xmlns:a16="http://schemas.microsoft.com/office/drawing/2014/main" id="{727838C2-EF49-84E9-A25B-D590A5E4B04C}"/>
               </a:ext>
             </a:extLst>
           </p:cNvPr>
@@ -8631,7 +8703,7 @@
           <p:cNvPr id="4" name="文本框 3">
             <a:extLst>
               <a:ext uri="{FF2B5EF4-FFF2-40B4-BE49-F238E27FC236}">
-                <a16:creationId xmlns:a16="http://schemas.microsoft.com/office/drawing/2014/main" id="{AD077E68-BE37-0B5E-93E1-6511FDB66EF1}"/>
+                <a16:creationId xmlns:a16="http://schemas.microsoft.com/office/drawing/2014/main" id="{ABD7F302-C89D-E5BE-933E-EDE8C819A722}"/>
               </a:ext>
             </a:extLst>
           </p:cNvPr>
@@ -8734,7 +8806,7 @@
           <p:cNvPr id="5" name="矩形 4">
             <a:extLst>
               <a:ext uri="{FF2B5EF4-FFF2-40B4-BE49-F238E27FC236}">
-                <a16:creationId xmlns:a16="http://schemas.microsoft.com/office/drawing/2014/main" id="{CE287458-38AB-0B6D-6AA3-ED298112776D}"/>
+                <a16:creationId xmlns:a16="http://schemas.microsoft.com/office/drawing/2014/main" id="{8B9DF817-AB87-3931-B97B-9FE566F21173}"/>
               </a:ext>
             </a:extLst>
           </p:cNvPr>
@@ -8802,7 +8874,7 @@
           <p:cNvPr id="6" name="文本框 5">
             <a:extLst>
               <a:ext uri="{FF2B5EF4-FFF2-40B4-BE49-F238E27FC236}">
-                <a16:creationId xmlns:a16="http://schemas.microsoft.com/office/drawing/2014/main" id="{4B553A71-D15F-54C4-046B-8A3229FC44BC}"/>
+                <a16:creationId xmlns:a16="http://schemas.microsoft.com/office/drawing/2014/main" id="{326429FE-D5AE-9E60-DF96-D383C508D32C}"/>
               </a:ext>
             </a:extLst>
           </p:cNvPr>
@@ -8900,7 +8972,7 @@
           <p:cNvPr id="7" name="文本框 6">
             <a:extLst>
               <a:ext uri="{FF2B5EF4-FFF2-40B4-BE49-F238E27FC236}">
-                <a16:creationId xmlns:a16="http://schemas.microsoft.com/office/drawing/2014/main" id="{EF059785-1AA6-4EF1-7778-F3EFE478CF42}"/>
+                <a16:creationId xmlns:a16="http://schemas.microsoft.com/office/drawing/2014/main" id="{6246D7F3-997A-4203-E94D-CA754F69AD4D}"/>
               </a:ext>
             </a:extLst>
           </p:cNvPr>
@@ -8976,7 +9048,7 @@
     </p:spTree>
     <p:extLst>
       <p:ext uri="{BB962C8B-B14F-4D97-AF65-F5344CB8AC3E}">
-        <p14:creationId xmlns:p14="http://schemas.microsoft.com/office/powerpoint/2010/main" val="439841798"/>
+        <p14:creationId xmlns:p14="http://schemas.microsoft.com/office/powerpoint/2010/main" val="2722800066"/>
       </p:ext>
     </p:extLst>
   </p:cSld>
@@ -9008,7 +9080,7 @@
           <p:cNvPr id="2" name="矩形 1">
             <a:extLst>
               <a:ext uri="{FF2B5EF4-FFF2-40B4-BE49-F238E27FC236}">
-                <a16:creationId xmlns:a16="http://schemas.microsoft.com/office/drawing/2014/main" id="{191AFD65-9F8D-23DD-5A1C-A2E332F76D5B}"/>
+                <a16:creationId xmlns:a16="http://schemas.microsoft.com/office/drawing/2014/main" id="{8FBE1A7D-258C-ADA9-11DC-62DD2C13F06E}"/>
               </a:ext>
             </a:extLst>
           </p:cNvPr>
@@ -9076,7 +9148,7 @@
           <p:cNvPr id="3" name="文本框 2">
             <a:extLst>
               <a:ext uri="{FF2B5EF4-FFF2-40B4-BE49-F238E27FC236}">
-                <a16:creationId xmlns:a16="http://schemas.microsoft.com/office/drawing/2014/main" id="{DD4C91A2-D0ED-59B1-1658-D0696655D0E2}"/>
+                <a16:creationId xmlns:a16="http://schemas.microsoft.com/office/drawing/2014/main" id="{94A1B49C-A584-10E7-99EB-1824B79EDCA2}"/>
               </a:ext>
             </a:extLst>
           </p:cNvPr>
@@ -9157,7 +9229,7 @@
           <p:cNvPr id="4" name="文本框 3">
             <a:extLst>
               <a:ext uri="{FF2B5EF4-FFF2-40B4-BE49-F238E27FC236}">
-                <a16:creationId xmlns:a16="http://schemas.microsoft.com/office/drawing/2014/main" id="{2B15EFAE-6454-7643-1E98-FE1DF3EA3462}"/>
+                <a16:creationId xmlns:a16="http://schemas.microsoft.com/office/drawing/2014/main" id="{6C142C44-360A-1752-BD8E-21D97E723F77}"/>
               </a:ext>
             </a:extLst>
           </p:cNvPr>
@@ -9270,7 +9342,7 @@
           <p:cNvPr id="5" name="矩形 4">
             <a:extLst>
               <a:ext uri="{FF2B5EF4-FFF2-40B4-BE49-F238E27FC236}">
-                <a16:creationId xmlns:a16="http://schemas.microsoft.com/office/drawing/2014/main" id="{78077EA5-9FB1-0309-3FAB-F2DE4BDC3B97}"/>
+                <a16:creationId xmlns:a16="http://schemas.microsoft.com/office/drawing/2014/main" id="{D3781C5F-EBEF-5212-4DA6-E853659781E3}"/>
               </a:ext>
             </a:extLst>
           </p:cNvPr>
@@ -9338,7 +9410,7 @@
           <p:cNvPr id="6" name="文本框 5">
             <a:extLst>
               <a:ext uri="{FF2B5EF4-FFF2-40B4-BE49-F238E27FC236}">
-                <a16:creationId xmlns:a16="http://schemas.microsoft.com/office/drawing/2014/main" id="{45BA935E-8A50-ECCB-6CD2-0FC151CE6951}"/>
+                <a16:creationId xmlns:a16="http://schemas.microsoft.com/office/drawing/2014/main" id="{A28C7537-D225-2186-551A-523BBFB8069E}"/>
               </a:ext>
             </a:extLst>
           </p:cNvPr>
@@ -9419,7 +9491,7 @@
           <p:cNvPr id="7" name="文本框 6">
             <a:extLst>
               <a:ext uri="{FF2B5EF4-FFF2-40B4-BE49-F238E27FC236}">
-                <a16:creationId xmlns:a16="http://schemas.microsoft.com/office/drawing/2014/main" id="{09B7C921-3162-2D5D-1AA2-BB8FDFE27569}"/>
+                <a16:creationId xmlns:a16="http://schemas.microsoft.com/office/drawing/2014/main" id="{420F5606-C2AB-9C84-FE20-28F59C529159}"/>
               </a:ext>
             </a:extLst>
           </p:cNvPr>
@@ -9495,7 +9567,7 @@
     </p:spTree>
     <p:extLst>
       <p:ext uri="{BB962C8B-B14F-4D97-AF65-F5344CB8AC3E}">
-        <p14:creationId xmlns:p14="http://schemas.microsoft.com/office/powerpoint/2010/main" val="3883079972"/>
+        <p14:creationId xmlns:p14="http://schemas.microsoft.com/office/powerpoint/2010/main" val="2253066141"/>
       </p:ext>
     </p:extLst>
   </p:cSld>
@@ -9527,7 +9599,7 @@
           <p:cNvPr id="2" name="矩形 1">
             <a:extLst>
               <a:ext uri="{FF2B5EF4-FFF2-40B4-BE49-F238E27FC236}">
-                <a16:creationId xmlns:a16="http://schemas.microsoft.com/office/drawing/2014/main" id="{CDB839EA-9B28-0FE6-B931-C3D63F5390C6}"/>
+                <a16:creationId xmlns:a16="http://schemas.microsoft.com/office/drawing/2014/main" id="{337DC620-C1C9-DE90-075D-6FF905507709}"/>
               </a:ext>
             </a:extLst>
           </p:cNvPr>
@@ -9595,7 +9667,7 @@
           <p:cNvPr id="3" name="文本框 2">
             <a:extLst>
               <a:ext uri="{FF2B5EF4-FFF2-40B4-BE49-F238E27FC236}">
-                <a16:creationId xmlns:a16="http://schemas.microsoft.com/office/drawing/2014/main" id="{8B1BC295-3349-D6C2-92CC-633FF23175B0}"/>
+                <a16:creationId xmlns:a16="http://schemas.microsoft.com/office/drawing/2014/main" id="{769086BD-7F81-6485-648D-F1F744591955}"/>
               </a:ext>
             </a:extLst>
           </p:cNvPr>
@@ -9656,7 +9728,7 @@
           <p:cNvPr id="4" name="文本框 3">
             <a:extLst>
               <a:ext uri="{FF2B5EF4-FFF2-40B4-BE49-F238E27FC236}">
-                <a16:creationId xmlns:a16="http://schemas.microsoft.com/office/drawing/2014/main" id="{AEC9787C-7A45-3319-3BA5-86CBB40D8FFA}"/>
+                <a16:creationId xmlns:a16="http://schemas.microsoft.com/office/drawing/2014/main" id="{3706152C-D38C-3323-C1DA-BDA614CFB082}"/>
               </a:ext>
             </a:extLst>
           </p:cNvPr>
@@ -9729,7 +9801,7 @@
           <p:cNvPr id="5" name="矩形 4">
             <a:extLst>
               <a:ext uri="{FF2B5EF4-FFF2-40B4-BE49-F238E27FC236}">
-                <a16:creationId xmlns:a16="http://schemas.microsoft.com/office/drawing/2014/main" id="{0D72D510-85F9-BD42-1F6F-28B9F6E08D96}"/>
+                <a16:creationId xmlns:a16="http://schemas.microsoft.com/office/drawing/2014/main" id="{39CF5067-BE18-47FE-CBA6-FE34A7B9D743}"/>
               </a:ext>
             </a:extLst>
           </p:cNvPr>
@@ -9797,7 +9869,7 @@
           <p:cNvPr id="6" name="文本框 5">
             <a:extLst>
               <a:ext uri="{FF2B5EF4-FFF2-40B4-BE49-F238E27FC236}">
-                <a16:creationId xmlns:a16="http://schemas.microsoft.com/office/drawing/2014/main" id="{0C222351-1349-0467-A295-F2EC150D6FB6}"/>
+                <a16:creationId xmlns:a16="http://schemas.microsoft.com/office/drawing/2014/main" id="{420335A6-022D-CB78-0755-1E0DFA04B970}"/>
               </a:ext>
             </a:extLst>
           </p:cNvPr>
@@ -9858,7 +9930,7 @@
           <p:cNvPr id="7" name="文本框 6">
             <a:extLst>
               <a:ext uri="{FF2B5EF4-FFF2-40B4-BE49-F238E27FC236}">
-                <a16:creationId xmlns:a16="http://schemas.microsoft.com/office/drawing/2014/main" id="{0A4D03A1-4D8C-E5E7-65F2-514CB0337406}"/>
+                <a16:creationId xmlns:a16="http://schemas.microsoft.com/office/drawing/2014/main" id="{E395F44D-9472-F747-9304-D8782371AA15}"/>
               </a:ext>
             </a:extLst>
           </p:cNvPr>
@@ -9934,7 +10006,7 @@
     </p:spTree>
     <p:extLst>
       <p:ext uri="{BB962C8B-B14F-4D97-AF65-F5344CB8AC3E}">
-        <p14:creationId xmlns:p14="http://schemas.microsoft.com/office/powerpoint/2010/main" val="1578001873"/>
+        <p14:creationId xmlns:p14="http://schemas.microsoft.com/office/powerpoint/2010/main" val="1891279312"/>
       </p:ext>
     </p:extLst>
   </p:cSld>
@@ -9966,7 +10038,7 @@
           <p:cNvPr id="2" name="矩形 1">
             <a:extLst>
               <a:ext uri="{FF2B5EF4-FFF2-40B4-BE49-F238E27FC236}">
-                <a16:creationId xmlns:a16="http://schemas.microsoft.com/office/drawing/2014/main" id="{E6FE001D-1116-4B1E-566E-C29AE3B346CA}"/>
+                <a16:creationId xmlns:a16="http://schemas.microsoft.com/office/drawing/2014/main" id="{89270A7C-8E8A-DBA6-6806-FB31C26F0F8B}"/>
               </a:ext>
             </a:extLst>
           </p:cNvPr>
@@ -10034,7 +10106,7 @@
           <p:cNvPr id="3" name="文本框 2">
             <a:extLst>
               <a:ext uri="{FF2B5EF4-FFF2-40B4-BE49-F238E27FC236}">
-                <a16:creationId xmlns:a16="http://schemas.microsoft.com/office/drawing/2014/main" id="{D97ACB7A-108F-D2AD-F6F1-CC4DD204F421}"/>
+                <a16:creationId xmlns:a16="http://schemas.microsoft.com/office/drawing/2014/main" id="{ADA0EF6E-98A3-7BAA-1C90-BC06F723C8E5}"/>
               </a:ext>
             </a:extLst>
           </p:cNvPr>
@@ -10075,7 +10147,7 @@
           <p:cNvPr id="4" name="文本框 3">
             <a:extLst>
               <a:ext uri="{FF2B5EF4-FFF2-40B4-BE49-F238E27FC236}">
-                <a16:creationId xmlns:a16="http://schemas.microsoft.com/office/drawing/2014/main" id="{F9015E80-8662-60BE-F46E-8BBD001C60C6}"/>
+                <a16:creationId xmlns:a16="http://schemas.microsoft.com/office/drawing/2014/main" id="{4E947656-D27E-406E-4936-BC3B67E7E97D}"/>
               </a:ext>
             </a:extLst>
           </p:cNvPr>
@@ -10198,7 +10270,7 @@
           <p:cNvPr id="5" name="矩形 4">
             <a:extLst>
               <a:ext uri="{FF2B5EF4-FFF2-40B4-BE49-F238E27FC236}">
-                <a16:creationId xmlns:a16="http://schemas.microsoft.com/office/drawing/2014/main" id="{7EDB38F6-6FA3-4BF1-D634-87AA7A105A25}"/>
+                <a16:creationId xmlns:a16="http://schemas.microsoft.com/office/drawing/2014/main" id="{611908F4-563C-013D-F64E-71783A2103E9}"/>
               </a:ext>
             </a:extLst>
           </p:cNvPr>
@@ -10266,7 +10338,7 @@
           <p:cNvPr id="6" name="文本框 5">
             <a:extLst>
               <a:ext uri="{FF2B5EF4-FFF2-40B4-BE49-F238E27FC236}">
-                <a16:creationId xmlns:a16="http://schemas.microsoft.com/office/drawing/2014/main" id="{F52375ED-020E-B966-9ADE-EC303667AAF6}"/>
+                <a16:creationId xmlns:a16="http://schemas.microsoft.com/office/drawing/2014/main" id="{DC2F0BA1-7FCA-9350-F928-4C81936A5279}"/>
               </a:ext>
             </a:extLst>
           </p:cNvPr>
@@ -10324,7 +10396,7 @@
           <p:cNvPr id="7" name="文本框 6">
             <a:extLst>
               <a:ext uri="{FF2B5EF4-FFF2-40B4-BE49-F238E27FC236}">
-                <a16:creationId xmlns:a16="http://schemas.microsoft.com/office/drawing/2014/main" id="{6EE73C77-431F-C5C9-FA23-24E2CDDA9A3B}"/>
+                <a16:creationId xmlns:a16="http://schemas.microsoft.com/office/drawing/2014/main" id="{B50AA95F-5624-D910-6607-4736D0EA7EBA}"/>
               </a:ext>
             </a:extLst>
           </p:cNvPr>
@@ -10400,7 +10472,7 @@
     </p:spTree>
     <p:extLst>
       <p:ext uri="{BB962C8B-B14F-4D97-AF65-F5344CB8AC3E}">
-        <p14:creationId xmlns:p14="http://schemas.microsoft.com/office/powerpoint/2010/main" val="3080383608"/>
+        <p14:creationId xmlns:p14="http://schemas.microsoft.com/office/powerpoint/2010/main" val="3898864230"/>
       </p:ext>
     </p:extLst>
   </p:cSld>

</xml_diff>